<commit_message>
feat: show NMT pipeline stages (Corpus, Tokenizer, Embedding, Word Vectors, Seq2Seq, LoRA) in system and slides
</commit_message>
<xml_diff>
--- a/comparativa_tokenizadores.pptx
+++ b/comparativa_tokenizadores.pptx
@@ -14,6 +14,10 @@
     <p:sldId id="262" r:id="rId13"/>
     <p:sldId id="263" r:id="rId14"/>
     <p:sldId id="264" r:id="rId15"/>
+    <p:sldId id="265" r:id="rId16"/>
+    <p:sldId id="266" r:id="rId17"/>
+    <p:sldId id="267" r:id="rId18"/>
+    <p:sldId id="268" r:id="rId19"/>
   </p:sldIdLst>
   <p:sldSz cx="12188952" cy="6858000" type="screen4x3"/>
   <p:notesSz cx="6858000" cy="9144000"/>
@@ -3500,6 +3504,1737 @@
 </p:sld>
 </file>
 
+<file path=ppt/slides/slide10.xml><?xml version="1.0" encoding="utf-8"?>
+<p:sld xmlns:a="http://schemas.openxmlformats.org/drawingml/2006/main" xmlns:p="http://schemas.openxmlformats.org/presentationml/2006/main" xmlns:r="http://schemas.openxmlformats.org/officeDocument/2006/relationships">
+  <p:cSld>
+    <p:bg>
+      <p:bgPr>
+        <a:solidFill>
+          <a:srgbClr val="0A0C16"/>
+        </a:solidFill>
+        <a:effectLst/>
+      </p:bgPr>
+    </p:bg>
+    <p:spTree>
+      <p:nvGrpSpPr>
+        <p:cNvPr id="1" name=""/>
+        <p:cNvGrpSpPr/>
+        <p:nvPr/>
+      </p:nvGrpSpPr>
+      <p:grpSpPr/>
+      <p:sp>
+        <p:nvSpPr>
+          <p:cNvPr id="2" name="Rectangle 1"/>
+          <p:cNvSpPr/>
+          <p:nvPr/>
+        </p:nvSpPr>
+        <p:spPr>
+          <a:xfrm>
+            <a:off x="0" y="0"/>
+            <a:ext cx="12188952" cy="82296"/>
+          </a:xfrm>
+          <a:prstGeom prst="rect">
+            <a:avLst/>
+          </a:prstGeom>
+          <a:solidFill>
+            <a:srgbClr val="8B5CF6"/>
+          </a:solidFill>
+          <a:ln>
+            <a:noFill/>
+          </a:ln>
+        </p:spPr>
+        <p:style>
+          <a:lnRef idx="1">
+            <a:schemeClr val="accent1"/>
+          </a:lnRef>
+          <a:fillRef idx="3">
+            <a:schemeClr val="accent1"/>
+          </a:fillRef>
+          <a:effectRef idx="2">
+            <a:schemeClr val="accent1"/>
+          </a:effectRef>
+          <a:fontRef idx="minor">
+            <a:schemeClr val="lt1"/>
+          </a:fontRef>
+        </p:style>
+        <p:txBody>
+          <a:bodyPr rtlCol="0" anchor="ctr"/>
+          <a:lstStyle/>
+          <a:p>
+            <a:pPr algn="ctr"/>
+          </a:p>
+        </p:txBody>
+      </p:sp>
+      <p:sp>
+        <p:nvSpPr>
+          <p:cNvPr id="3" name="Rectangle 2"/>
+          <p:cNvSpPr/>
+          <p:nvPr/>
+        </p:nvSpPr>
+        <p:spPr>
+          <a:xfrm>
+            <a:off x="0" y="6793992"/>
+            <a:ext cx="12188952" cy="64008"/>
+          </a:xfrm>
+          <a:prstGeom prst="rect">
+            <a:avLst/>
+          </a:prstGeom>
+          <a:solidFill>
+            <a:srgbClr val="1E293B"/>
+          </a:solidFill>
+          <a:ln>
+            <a:noFill/>
+          </a:ln>
+        </p:spPr>
+        <p:style>
+          <a:lnRef idx="1">
+            <a:schemeClr val="accent1"/>
+          </a:lnRef>
+          <a:fillRef idx="3">
+            <a:schemeClr val="accent1"/>
+          </a:fillRef>
+          <a:effectRef idx="2">
+            <a:schemeClr val="accent1"/>
+          </a:effectRef>
+          <a:fontRef idx="minor">
+            <a:schemeClr val="lt1"/>
+          </a:fontRef>
+        </p:style>
+        <p:txBody>
+          <a:bodyPr rtlCol="0" anchor="ctr"/>
+          <a:lstStyle/>
+          <a:p>
+            <a:pPr algn="ctr"/>
+          </a:p>
+        </p:txBody>
+      </p:sp>
+      <p:sp>
+        <p:nvSpPr>
+          <p:cNvPr id="4" name="TextBox 3"/>
+          <p:cNvSpPr txBox="1"/>
+          <p:nvPr/>
+        </p:nvSpPr>
+        <p:spPr>
+          <a:xfrm>
+            <a:off x="11430000" y="6537960"/>
+            <a:ext cx="731520" cy="274320"/>
+          </a:xfrm>
+          <a:prstGeom prst="rect">
+            <a:avLst/>
+          </a:prstGeom>
+          <a:noFill/>
+        </p:spPr>
+        <p:txBody>
+          <a:bodyPr wrap="none">
+            <a:spAutoFit/>
+          </a:bodyPr>
+          <a:lstStyle/>
+          <a:p/>
+          <a:p>
+            <a:pPr algn="r">
+              <a:spcBef>
+                <a:spcPts val="0"/>
+              </a:spcBef>
+              <a:spcAft>
+                <a:spcPts val="600"/>
+              </a:spcAft>
+              <a:defRPr sz="800" b="0" i="0">
+                <a:solidFill>
+                  <a:srgbClr val="94A3B8"/>
+                </a:solidFill>
+                <a:latin typeface="Arial"/>
+              </a:defRPr>
+            </a:pPr>
+            <a:r>
+              <a:t>10 / 13</a:t>
+            </a:r>
+          </a:p>
+        </p:txBody>
+      </p:sp>
+      <p:sp>
+        <p:nvSpPr>
+          <p:cNvPr id="5" name="TextBox 4"/>
+          <p:cNvSpPr txBox="1"/>
+          <p:nvPr/>
+        </p:nvSpPr>
+        <p:spPr>
+          <a:xfrm>
+            <a:off x="548640" y="182880"/>
+            <a:ext cx="11064240" cy="731520"/>
+          </a:xfrm>
+          <a:prstGeom prst="rect">
+            <a:avLst/>
+          </a:prstGeom>
+          <a:noFill/>
+        </p:spPr>
+        <p:txBody>
+          <a:bodyPr wrap="none">
+            <a:spAutoFit/>
+          </a:bodyPr>
+          <a:lstStyle/>
+          <a:p/>
+          <a:p>
+            <a:pPr algn="l">
+              <a:spcBef>
+                <a:spcPts val="0"/>
+              </a:spcBef>
+              <a:spcAft>
+                <a:spcPts val="400"/>
+              </a:spcAft>
+              <a:defRPr sz="850" b="1" i="0">
+                <a:solidFill>
+                  <a:srgbClr val="06B6D4"/>
+                </a:solidFill>
+                <a:latin typeface="Arial"/>
+              </a:defRPr>
+            </a:pPr>
+            <a:r>
+              <a:t>EVIDENCIA CUANTITATIVA DE TOKENIZACIÓN</a:t>
+            </a:r>
+          </a:p>
+          <a:p>
+            <a:pPr algn="l">
+              <a:spcBef>
+                <a:spcPts val="0"/>
+              </a:spcBef>
+              <a:spcAft>
+                <a:spcPts val="800"/>
+              </a:spcAft>
+              <a:defRPr sz="2300" b="1" i="0">
+                <a:solidFill>
+                  <a:srgbClr val="FFFFFF"/>
+                </a:solidFill>
+                <a:latin typeface="Arial"/>
+              </a:defRPr>
+            </a:pPr>
+            <a:r>
+              <a:t>Coherencia de Slicing: Longitud Promedio de Tokens</a:t>
+            </a:r>
+          </a:p>
+        </p:txBody>
+      </p:sp>
+      <p:pic>
+        <p:nvPicPr>
+          <p:cNvPr id="6" name="Picture 5" descr="image.png"/>
+          <p:cNvPicPr>
+            <a:picLocks noChangeAspect="1"/>
+          </p:cNvPicPr>
+          <p:nvPr/>
+        </p:nvPicPr>
+        <p:blipFill>
+          <a:blip r:embed="rId2"/>
+          <a:stretch>
+            <a:fillRect/>
+          </a:stretch>
+        </p:blipFill>
+        <p:spPr>
+          <a:xfrm>
+            <a:off x="548640" y="1188720"/>
+            <a:ext cx="6858000" cy="4114800"/>
+          </a:xfrm>
+          <a:prstGeom prst="rect">
+            <a:avLst/>
+          </a:prstGeom>
+        </p:spPr>
+      </p:pic>
+      <p:sp>
+        <p:nvSpPr>
+          <p:cNvPr id="7" name="Rectangle 6"/>
+          <p:cNvSpPr/>
+          <p:nvPr/>
+        </p:nvSpPr>
+        <p:spPr>
+          <a:xfrm>
+            <a:off x="7680960" y="1188720"/>
+            <a:ext cx="3931920" cy="4114800"/>
+          </a:xfrm>
+          <a:prstGeom prst="rect">
+            <a:avLst/>
+          </a:prstGeom>
+          <a:solidFill>
+            <a:srgbClr val="121626"/>
+          </a:solidFill>
+          <a:ln w="12700">
+            <a:solidFill>
+              <a:srgbClr val="06B6D4"/>
+            </a:solidFill>
+          </a:ln>
+        </p:spPr>
+        <p:style>
+          <a:lnRef idx="1">
+            <a:schemeClr val="accent1"/>
+          </a:lnRef>
+          <a:fillRef idx="3">
+            <a:schemeClr val="accent1"/>
+          </a:fillRef>
+          <a:effectRef idx="2">
+            <a:schemeClr val="accent1"/>
+          </a:effectRef>
+          <a:fontRef idx="minor">
+            <a:schemeClr val="lt1"/>
+          </a:fontRef>
+        </p:style>
+        <p:txBody>
+          <a:bodyPr rtlCol="0" anchor="ctr"/>
+          <a:lstStyle/>
+          <a:p>
+            <a:pPr algn="ctr"/>
+          </a:p>
+        </p:txBody>
+      </p:sp>
+      <p:sp>
+        <p:nvSpPr>
+          <p:cNvPr id="8" name="TextBox 7"/>
+          <p:cNvSpPr txBox="1"/>
+          <p:nvPr/>
+        </p:nvSpPr>
+        <p:spPr>
+          <a:xfrm>
+            <a:off x="7863840" y="1371600"/>
+            <a:ext cx="3566160" cy="3749039"/>
+          </a:xfrm>
+          <a:prstGeom prst="rect">
+            <a:avLst/>
+          </a:prstGeom>
+          <a:noFill/>
+        </p:spPr>
+        <p:txBody>
+          <a:bodyPr wrap="square">
+            <a:spAutoFit/>
+          </a:bodyPr>
+          <a:lstStyle/>
+          <a:p/>
+          <a:p>
+            <a:pPr algn="l">
+              <a:spcBef>
+                <a:spcPts val="0"/>
+              </a:spcBef>
+              <a:spcAft>
+                <a:spcPts val="800"/>
+              </a:spcAft>
+              <a:defRPr sz="1400" b="1" i="0">
+                <a:solidFill>
+                  <a:srgbClr val="06B6D4"/>
+                </a:solidFill>
+                <a:latin typeface="Arial"/>
+              </a:defRPr>
+            </a:pPr>
+            <a:r>
+              <a:t>Longitud y Coherencia Semántica</a:t>
+            </a:r>
+          </a:p>
+          <a:p>
+            <a:pPr algn="l">
+              <a:spcBef>
+                <a:spcPts val="0"/>
+              </a:spcBef>
+              <a:spcAft>
+                <a:spcPts val="600"/>
+              </a:spcAft>
+              <a:defRPr sz="1150" b="0" i="0">
+                <a:solidFill>
+                  <a:srgbClr val="FFFFFF"/>
+                </a:solidFill>
+                <a:latin typeface="Arial"/>
+              </a:defRPr>
+            </a:pPr>
+            <a:r>
+              <a:t>• NLLB-200 mantiene un promedio de 3.1 caracteres por token, resguardando la integridad semántica de raíces y morfemas.</a:t>
+            </a:r>
+          </a:p>
+          <a:p>
+            <a:pPr algn="l">
+              <a:spcBef>
+                <a:spcPts val="0"/>
+              </a:spcBef>
+              <a:spcAft>
+                <a:spcPts val="600"/>
+              </a:spcAft>
+              <a:defRPr sz="1150" b="0" i="0">
+                <a:solidFill>
+                  <a:srgbClr val="FFFFFF"/>
+                </a:solidFill>
+                <a:latin typeface="Arial"/>
+              </a:defRPr>
+            </a:pPr>
+            <a:r>
+              <a:t>• Llama-3 sufre una caída drástica a 2.0 caracteres por token, fragmentando a nivel de caracteres individuales sin semántica léxica.</a:t>
+            </a:r>
+          </a:p>
+          <a:p>
+            <a:pPr algn="l">
+              <a:spcBef>
+                <a:spcPts val="0"/>
+              </a:spcBef>
+              <a:spcAft>
+                <a:spcPts val="600"/>
+              </a:spcAft>
+              <a:defRPr sz="1150" b="0" i="0">
+                <a:solidFill>
+                  <a:srgbClr val="FFFFFF"/>
+                </a:solidFill>
+                <a:latin typeface="Arial"/>
+              </a:defRPr>
+            </a:pPr>
+            <a:r>
+              <a:t>• Gemma-2 promedia 3.8 caracteres por token debido a una estructura SP masiva que divide rígidamente bloques de longitud fija de 4 letras.</a:t>
+            </a:r>
+          </a:p>
+          <a:p>
+            <a:pPr algn="l">
+              <a:spcBef>
+                <a:spcPts val="0"/>
+              </a:spcBef>
+              <a:spcAft>
+                <a:spcPts val="400"/>
+              </a:spcAft>
+              <a:defRPr sz="700" b="0" i="0">
+                <a:solidFill>
+                  <a:srgbClr val="94A3B8"/>
+                </a:solidFill>
+                <a:latin typeface="Arial"/>
+              </a:defRPr>
+            </a:pPr>
+            <a:r>
+              <a:t>────────────────────────────────────────────────────────────────────</a:t>
+            </a:r>
+          </a:p>
+          <a:p>
+            <a:pPr algn="l">
+              <a:spcBef>
+                <a:spcPts val="0"/>
+              </a:spcBef>
+              <a:spcAft>
+                <a:spcPts val="600"/>
+              </a:spcAft>
+              <a:defRPr sz="1150" b="0" i="0">
+                <a:solidFill>
+                  <a:srgbClr val="FFFFFF"/>
+                </a:solidFill>
+                <a:latin typeface="Arial"/>
+              </a:defRPr>
+            </a:pPr>
+            <a:r>
+              <a:t>• Un largo de token balanceado que mapee con los límites morfológicos es la clave para la convergencia científica en lenguas polisintéticas.</a:t>
+            </a:r>
+          </a:p>
+        </p:txBody>
+      </p:sp>
+    </p:spTree>
+  </p:cSld>
+  <p:clrMapOvr>
+    <a:masterClrMapping/>
+  </p:clrMapOvr>
+</p:sld>
+</file>
+
+<file path=ppt/slides/slide11.xml><?xml version="1.0" encoding="utf-8"?>
+<p:sld xmlns:a="http://schemas.openxmlformats.org/drawingml/2006/main" xmlns:p="http://schemas.openxmlformats.org/presentationml/2006/main" xmlns:r="http://schemas.openxmlformats.org/officeDocument/2006/relationships">
+  <p:cSld>
+    <p:bg>
+      <p:bgPr>
+        <a:solidFill>
+          <a:srgbClr val="0A0C16"/>
+        </a:solidFill>
+        <a:effectLst/>
+      </p:bgPr>
+    </p:bg>
+    <p:spTree>
+      <p:nvGrpSpPr>
+        <p:cNvPr id="1" name=""/>
+        <p:cNvGrpSpPr/>
+        <p:nvPr/>
+      </p:nvGrpSpPr>
+      <p:grpSpPr/>
+      <p:sp>
+        <p:nvSpPr>
+          <p:cNvPr id="2" name="Rectangle 1"/>
+          <p:cNvSpPr/>
+          <p:nvPr/>
+        </p:nvSpPr>
+        <p:spPr>
+          <a:xfrm>
+            <a:off x="0" y="0"/>
+            <a:ext cx="12188952" cy="82296"/>
+          </a:xfrm>
+          <a:prstGeom prst="rect">
+            <a:avLst/>
+          </a:prstGeom>
+          <a:solidFill>
+            <a:srgbClr val="8B5CF6"/>
+          </a:solidFill>
+          <a:ln>
+            <a:noFill/>
+          </a:ln>
+        </p:spPr>
+        <p:style>
+          <a:lnRef idx="1">
+            <a:schemeClr val="accent1"/>
+          </a:lnRef>
+          <a:fillRef idx="3">
+            <a:schemeClr val="accent1"/>
+          </a:fillRef>
+          <a:effectRef idx="2">
+            <a:schemeClr val="accent1"/>
+          </a:effectRef>
+          <a:fontRef idx="minor">
+            <a:schemeClr val="lt1"/>
+          </a:fontRef>
+        </p:style>
+        <p:txBody>
+          <a:bodyPr rtlCol="0" anchor="ctr"/>
+          <a:lstStyle/>
+          <a:p>
+            <a:pPr algn="ctr"/>
+          </a:p>
+        </p:txBody>
+      </p:sp>
+      <p:sp>
+        <p:nvSpPr>
+          <p:cNvPr id="3" name="Rectangle 2"/>
+          <p:cNvSpPr/>
+          <p:nvPr/>
+        </p:nvSpPr>
+        <p:spPr>
+          <a:xfrm>
+            <a:off x="0" y="6793992"/>
+            <a:ext cx="12188952" cy="64008"/>
+          </a:xfrm>
+          <a:prstGeom prst="rect">
+            <a:avLst/>
+          </a:prstGeom>
+          <a:solidFill>
+            <a:srgbClr val="1E293B"/>
+          </a:solidFill>
+          <a:ln>
+            <a:noFill/>
+          </a:ln>
+        </p:spPr>
+        <p:style>
+          <a:lnRef idx="1">
+            <a:schemeClr val="accent1"/>
+          </a:lnRef>
+          <a:fillRef idx="3">
+            <a:schemeClr val="accent1"/>
+          </a:fillRef>
+          <a:effectRef idx="2">
+            <a:schemeClr val="accent1"/>
+          </a:effectRef>
+          <a:fontRef idx="minor">
+            <a:schemeClr val="lt1"/>
+          </a:fontRef>
+        </p:style>
+        <p:txBody>
+          <a:bodyPr rtlCol="0" anchor="ctr"/>
+          <a:lstStyle/>
+          <a:p>
+            <a:pPr algn="ctr"/>
+          </a:p>
+        </p:txBody>
+      </p:sp>
+      <p:sp>
+        <p:nvSpPr>
+          <p:cNvPr id="4" name="TextBox 3"/>
+          <p:cNvSpPr txBox="1"/>
+          <p:nvPr/>
+        </p:nvSpPr>
+        <p:spPr>
+          <a:xfrm>
+            <a:off x="11430000" y="6537960"/>
+            <a:ext cx="731520" cy="274320"/>
+          </a:xfrm>
+          <a:prstGeom prst="rect">
+            <a:avLst/>
+          </a:prstGeom>
+          <a:noFill/>
+        </p:spPr>
+        <p:txBody>
+          <a:bodyPr wrap="none">
+            <a:spAutoFit/>
+          </a:bodyPr>
+          <a:lstStyle/>
+          <a:p/>
+          <a:p>
+            <a:pPr algn="r">
+              <a:spcBef>
+                <a:spcPts val="0"/>
+              </a:spcBef>
+              <a:spcAft>
+                <a:spcPts val="600"/>
+              </a:spcAft>
+              <a:defRPr sz="800" b="0" i="0">
+                <a:solidFill>
+                  <a:srgbClr val="94A3B8"/>
+                </a:solidFill>
+                <a:latin typeface="Arial"/>
+              </a:defRPr>
+            </a:pPr>
+            <a:r>
+              <a:t>11 / 13</a:t>
+            </a:r>
+          </a:p>
+        </p:txBody>
+      </p:sp>
+      <p:sp>
+        <p:nvSpPr>
+          <p:cNvPr id="5" name="TextBox 4"/>
+          <p:cNvSpPr txBox="1"/>
+          <p:nvPr/>
+        </p:nvSpPr>
+        <p:spPr>
+          <a:xfrm>
+            <a:off x="548640" y="182880"/>
+            <a:ext cx="11064240" cy="731520"/>
+          </a:xfrm>
+          <a:prstGeom prst="rect">
+            <a:avLst/>
+          </a:prstGeom>
+          <a:noFill/>
+        </p:spPr>
+        <p:txBody>
+          <a:bodyPr wrap="none">
+            <a:spAutoFit/>
+          </a:bodyPr>
+          <a:lstStyle/>
+          <a:p/>
+          <a:p>
+            <a:pPr algn="l">
+              <a:spcBef>
+                <a:spcPts val="0"/>
+              </a:spcBef>
+              <a:spcAft>
+                <a:spcPts val="400"/>
+              </a:spcAft>
+              <a:defRPr sz="850" b="1" i="0">
+                <a:solidFill>
+                  <a:srgbClr val="06B6D4"/>
+                </a:solidFill>
+                <a:latin typeface="Arial"/>
+              </a:defRPr>
+            </a:pPr>
+            <a:r>
+              <a:t>DIDÁCTICA DE LA INTELIGENCIA ARTIFICIAL</a:t>
+            </a:r>
+          </a:p>
+          <a:p>
+            <a:pPr algn="l">
+              <a:spcBef>
+                <a:spcPts val="0"/>
+              </a:spcBef>
+              <a:spcAft>
+                <a:spcPts val="800"/>
+              </a:spcAft>
+              <a:defRPr sz="2400" b="1" i="0">
+                <a:solidFill>
+                  <a:srgbClr val="FFFFFF"/>
+                </a:solidFill>
+                <a:latin typeface="Arial"/>
+              </a:defRPr>
+            </a:pPr>
+            <a:r>
+              <a:t>La Analogía Didáctica: Bloques LEGO y las Tijeras Inteligentes</a:t>
+            </a:r>
+          </a:p>
+        </p:txBody>
+      </p:sp>
+      <p:pic>
+        <p:nvPicPr>
+          <p:cNvPr id="6" name="Picture 5" descr="image.png"/>
+          <p:cNvPicPr>
+            <a:picLocks noChangeAspect="1"/>
+          </p:cNvPicPr>
+          <p:nvPr/>
+        </p:nvPicPr>
+        <p:blipFill>
+          <a:blip r:embed="rId2"/>
+          <a:stretch>
+            <a:fillRect/>
+          </a:stretch>
+        </p:blipFill>
+        <p:spPr>
+          <a:xfrm>
+            <a:off x="548640" y="1188720"/>
+            <a:ext cx="11064240" cy="3017520"/>
+          </a:xfrm>
+          <a:prstGeom prst="rect">
+            <a:avLst/>
+          </a:prstGeom>
+        </p:spPr>
+      </p:pic>
+      <p:sp>
+        <p:nvSpPr>
+          <p:cNvPr id="7" name="Rectangle 6"/>
+          <p:cNvSpPr/>
+          <p:nvPr/>
+        </p:nvSpPr>
+        <p:spPr>
+          <a:xfrm>
+            <a:off x="548640" y="4389120"/>
+            <a:ext cx="11064240" cy="2011680"/>
+          </a:xfrm>
+          <a:prstGeom prst="rect">
+            <a:avLst/>
+          </a:prstGeom>
+          <a:solidFill>
+            <a:srgbClr val="121626"/>
+          </a:solidFill>
+          <a:ln w="12700">
+            <a:solidFill>
+              <a:srgbClr val="8B5CF6"/>
+            </a:solidFill>
+          </a:ln>
+        </p:spPr>
+        <p:style>
+          <a:lnRef idx="1">
+            <a:schemeClr val="accent1"/>
+          </a:lnRef>
+          <a:fillRef idx="3">
+            <a:schemeClr val="accent1"/>
+          </a:fillRef>
+          <a:effectRef idx="2">
+            <a:schemeClr val="accent1"/>
+          </a:effectRef>
+          <a:fontRef idx="minor">
+            <a:schemeClr val="lt1"/>
+          </a:fontRef>
+        </p:style>
+        <p:txBody>
+          <a:bodyPr rtlCol="0" anchor="ctr"/>
+          <a:lstStyle/>
+          <a:p>
+            <a:pPr algn="ctr"/>
+          </a:p>
+        </p:txBody>
+      </p:sp>
+      <p:sp>
+        <p:nvSpPr>
+          <p:cNvPr id="8" name="TextBox 7"/>
+          <p:cNvSpPr txBox="1"/>
+          <p:nvPr/>
+        </p:nvSpPr>
+        <p:spPr>
+          <a:xfrm>
+            <a:off x="731520" y="4480560"/>
+            <a:ext cx="10698480" cy="1828800"/>
+          </a:xfrm>
+          <a:prstGeom prst="rect">
+            <a:avLst/>
+          </a:prstGeom>
+          <a:noFill/>
+        </p:spPr>
+        <p:txBody>
+          <a:bodyPr wrap="square">
+            <a:spAutoFit/>
+          </a:bodyPr>
+          <a:lstStyle/>
+          <a:p/>
+          <a:p>
+            <a:pPr algn="l">
+              <a:spcBef>
+                <a:spcPts val="0"/>
+              </a:spcBef>
+              <a:spcAft>
+                <a:spcPts val="800"/>
+              </a:spcAft>
+              <a:defRPr sz="1400" b="1" i="0">
+                <a:solidFill>
+                  <a:srgbClr val="06B6D4"/>
+                </a:solidFill>
+                <a:latin typeface="Arial"/>
+              </a:defRPr>
+            </a:pPr>
+            <a:r>
+              <a:t>Explicación Didáctica para Ponencias Académicas</a:t>
+            </a:r>
+          </a:p>
+          <a:p>
+            <a:pPr algn="l">
+              <a:spcBef>
+                <a:spcPts val="0"/>
+              </a:spcBef>
+              <a:spcAft>
+                <a:spcPts val="600"/>
+              </a:spcAft>
+              <a:defRPr sz="1150" b="0" i="0">
+                <a:solidFill>
+                  <a:srgbClr val="FFFFFF"/>
+                </a:solidFill>
+                <a:latin typeface="Arial"/>
+              </a:defRPr>
+            </a:pPr>
+            <a:r>
+              <a:t>• El Aimara es como un juguete de bloques LEGO: las palabras largas se construyen encadenando pequeños bloquecitos (raíz + sufijos).</a:t>
+            </a:r>
+          </a:p>
+          <a:p>
+            <a:pPr algn="l">
+              <a:spcBef>
+                <a:spcPts val="0"/>
+              </a:spcBef>
+              <a:spcAft>
+                <a:spcPts val="600"/>
+              </a:spcAft>
+              <a:defRPr sz="1150" b="0" i="0">
+                <a:solidFill>
+                  <a:srgbClr val="FFFFFF"/>
+                </a:solidFill>
+                <a:latin typeface="Arial"/>
+              </a:defRPr>
+            </a:pPr>
+            <a:r>
+              <a:t>• NLLB-200 es como usar 'tijeras inteligentes': Corta la palabra en las uniones de los bloques LEGO reales. Así, es sumamente fácil entender el significado de cada pieza y volver a unirlas de forma lógica.</a:t>
+            </a:r>
+          </a:p>
+          <a:p>
+            <a:pPr algn="l">
+              <a:spcBef>
+                <a:spcPts val="0"/>
+              </a:spcBef>
+              <a:spcAft>
+                <a:spcPts val="600"/>
+              </a:spcAft>
+              <a:defRPr sz="1150" b="0" i="0">
+                <a:solidFill>
+                  <a:srgbClr val="FFFFFF"/>
+                </a:solidFill>
+                <a:latin typeface="Arial"/>
+              </a:defRPr>
+            </a:pPr>
+            <a:r>
+              <a:t>• Llama-3-8B es como usar 'tijeras rotas': No conoce el idioma y corta los bloques LEGO a la mitad, dejándolos en diminutas astillas de dos letras que no significan nada, colapsando el cerebro del Transformer.</a:t>
+            </a:r>
+          </a:p>
+        </p:txBody>
+      </p:sp>
+    </p:spTree>
+  </p:cSld>
+  <p:clrMapOvr>
+    <a:masterClrMapping/>
+  </p:clrMapOvr>
+</p:sld>
+</file>
+
+<file path=ppt/slides/slide12.xml><?xml version="1.0" encoding="utf-8"?>
+<p:sld xmlns:a="http://schemas.openxmlformats.org/drawingml/2006/main" xmlns:p="http://schemas.openxmlformats.org/presentationml/2006/main" xmlns:r="http://schemas.openxmlformats.org/officeDocument/2006/relationships">
+  <p:cSld>
+    <p:bg>
+      <p:bgPr>
+        <a:solidFill>
+          <a:srgbClr val="0A0C16"/>
+        </a:solidFill>
+        <a:effectLst/>
+      </p:bgPr>
+    </p:bg>
+    <p:spTree>
+      <p:nvGrpSpPr>
+        <p:cNvPr id="1" name=""/>
+        <p:cNvGrpSpPr/>
+        <p:nvPr/>
+      </p:nvGrpSpPr>
+      <p:grpSpPr/>
+      <p:sp>
+        <p:nvSpPr>
+          <p:cNvPr id="2" name="Rectangle 1"/>
+          <p:cNvSpPr/>
+          <p:nvPr/>
+        </p:nvSpPr>
+        <p:spPr>
+          <a:xfrm>
+            <a:off x="0" y="0"/>
+            <a:ext cx="12188952" cy="82296"/>
+          </a:xfrm>
+          <a:prstGeom prst="rect">
+            <a:avLst/>
+          </a:prstGeom>
+          <a:solidFill>
+            <a:srgbClr val="8B5CF6"/>
+          </a:solidFill>
+          <a:ln>
+            <a:noFill/>
+          </a:ln>
+        </p:spPr>
+        <p:style>
+          <a:lnRef idx="1">
+            <a:schemeClr val="accent1"/>
+          </a:lnRef>
+          <a:fillRef idx="3">
+            <a:schemeClr val="accent1"/>
+          </a:fillRef>
+          <a:effectRef idx="2">
+            <a:schemeClr val="accent1"/>
+          </a:effectRef>
+          <a:fontRef idx="minor">
+            <a:schemeClr val="lt1"/>
+          </a:fontRef>
+        </p:style>
+        <p:txBody>
+          <a:bodyPr rtlCol="0" anchor="ctr"/>
+          <a:lstStyle/>
+          <a:p>
+            <a:pPr algn="ctr"/>
+          </a:p>
+        </p:txBody>
+      </p:sp>
+      <p:sp>
+        <p:nvSpPr>
+          <p:cNvPr id="3" name="Rectangle 2"/>
+          <p:cNvSpPr/>
+          <p:nvPr/>
+        </p:nvSpPr>
+        <p:spPr>
+          <a:xfrm>
+            <a:off x="0" y="6793992"/>
+            <a:ext cx="12188952" cy="64008"/>
+          </a:xfrm>
+          <a:prstGeom prst="rect">
+            <a:avLst/>
+          </a:prstGeom>
+          <a:solidFill>
+            <a:srgbClr val="1E293B"/>
+          </a:solidFill>
+          <a:ln>
+            <a:noFill/>
+          </a:ln>
+        </p:spPr>
+        <p:style>
+          <a:lnRef idx="1">
+            <a:schemeClr val="accent1"/>
+          </a:lnRef>
+          <a:fillRef idx="3">
+            <a:schemeClr val="accent1"/>
+          </a:fillRef>
+          <a:effectRef idx="2">
+            <a:schemeClr val="accent1"/>
+          </a:effectRef>
+          <a:fontRef idx="minor">
+            <a:schemeClr val="lt1"/>
+          </a:fontRef>
+        </p:style>
+        <p:txBody>
+          <a:bodyPr rtlCol="0" anchor="ctr"/>
+          <a:lstStyle/>
+          <a:p>
+            <a:pPr algn="ctr"/>
+          </a:p>
+        </p:txBody>
+      </p:sp>
+      <p:sp>
+        <p:nvSpPr>
+          <p:cNvPr id="4" name="TextBox 3"/>
+          <p:cNvSpPr txBox="1"/>
+          <p:nvPr/>
+        </p:nvSpPr>
+        <p:spPr>
+          <a:xfrm>
+            <a:off x="11430000" y="6537960"/>
+            <a:ext cx="731520" cy="274320"/>
+          </a:xfrm>
+          <a:prstGeom prst="rect">
+            <a:avLst/>
+          </a:prstGeom>
+          <a:noFill/>
+        </p:spPr>
+        <p:txBody>
+          <a:bodyPr wrap="none">
+            <a:spAutoFit/>
+          </a:bodyPr>
+          <a:lstStyle/>
+          <a:p/>
+          <a:p>
+            <a:pPr algn="r">
+              <a:spcBef>
+                <a:spcPts val="0"/>
+              </a:spcBef>
+              <a:spcAft>
+                <a:spcPts val="600"/>
+              </a:spcAft>
+              <a:defRPr sz="800" b="0" i="0">
+                <a:solidFill>
+                  <a:srgbClr val="94A3B8"/>
+                </a:solidFill>
+                <a:latin typeface="Arial"/>
+              </a:defRPr>
+            </a:pPr>
+            <a:r>
+              <a:t>12 / 13</a:t>
+            </a:r>
+          </a:p>
+        </p:txBody>
+      </p:sp>
+      <p:sp>
+        <p:nvSpPr>
+          <p:cNvPr id="5" name="TextBox 4"/>
+          <p:cNvSpPr txBox="1"/>
+          <p:nvPr/>
+        </p:nvSpPr>
+        <p:spPr>
+          <a:xfrm>
+            <a:off x="548640" y="182880"/>
+            <a:ext cx="11064240" cy="731520"/>
+          </a:xfrm>
+          <a:prstGeom prst="rect">
+            <a:avLst/>
+          </a:prstGeom>
+          <a:noFill/>
+        </p:spPr>
+        <p:txBody>
+          <a:bodyPr wrap="none">
+            <a:spAutoFit/>
+          </a:bodyPr>
+          <a:lstStyle/>
+          <a:p/>
+          <a:p>
+            <a:pPr algn="l">
+              <a:spcBef>
+                <a:spcPts val="0"/>
+              </a:spcBef>
+              <a:spcAft>
+                <a:spcPts val="400"/>
+              </a:spcAft>
+              <a:defRPr sz="850" b="1" i="0">
+                <a:solidFill>
+                  <a:srgbClr val="06B6D4"/>
+                </a:solidFill>
+                <a:latin typeface="Arial"/>
+              </a:defRPr>
+            </a:pPr>
+            <a:r>
+              <a:t>MÉTRICAS CIENTÍFICAS</a:t>
+            </a:r>
+          </a:p>
+          <a:p>
+            <a:pPr algn="l">
+              <a:spcBef>
+                <a:spcPts val="0"/>
+              </a:spcBef>
+              <a:spcAft>
+                <a:spcPts val="800"/>
+              </a:spcAft>
+              <a:defRPr sz="2400" b="1" i="0">
+                <a:solidFill>
+                  <a:srgbClr val="FFFFFF"/>
+                </a:solidFill>
+                <a:latin typeface="Arial"/>
+              </a:defRPr>
+            </a:pPr>
+            <a:r>
+              <a:t>El Tribunal Científico: BLEU vs ChrF++ en Lenguas Sintéticas</a:t>
+            </a:r>
+          </a:p>
+        </p:txBody>
+      </p:sp>
+      <p:sp>
+        <p:nvSpPr>
+          <p:cNvPr id="6" name="Rectangle 5"/>
+          <p:cNvSpPr/>
+          <p:nvPr/>
+        </p:nvSpPr>
+        <p:spPr>
+          <a:xfrm>
+            <a:off x="548640" y="1188720"/>
+            <a:ext cx="5394960" cy="5212080"/>
+          </a:xfrm>
+          <a:prstGeom prst="rect">
+            <a:avLst/>
+          </a:prstGeom>
+          <a:solidFill>
+            <a:srgbClr val="121626"/>
+          </a:solidFill>
+          <a:ln w="12700">
+            <a:solidFill>
+              <a:srgbClr val="1E293B"/>
+            </a:solidFill>
+          </a:ln>
+        </p:spPr>
+        <p:style>
+          <a:lnRef idx="1">
+            <a:schemeClr val="accent1"/>
+          </a:lnRef>
+          <a:fillRef idx="3">
+            <a:schemeClr val="accent1"/>
+          </a:fillRef>
+          <a:effectRef idx="2">
+            <a:schemeClr val="accent1"/>
+          </a:effectRef>
+          <a:fontRef idx="minor">
+            <a:schemeClr val="lt1"/>
+          </a:fontRef>
+        </p:style>
+        <p:txBody>
+          <a:bodyPr rtlCol="0" anchor="ctr"/>
+          <a:lstStyle/>
+          <a:p>
+            <a:pPr algn="ctr"/>
+          </a:p>
+        </p:txBody>
+      </p:sp>
+      <p:sp>
+        <p:nvSpPr>
+          <p:cNvPr id="7" name="TextBox 6"/>
+          <p:cNvSpPr txBox="1"/>
+          <p:nvPr/>
+        </p:nvSpPr>
+        <p:spPr>
+          <a:xfrm>
+            <a:off x="713232" y="1353312"/>
+            <a:ext cx="5065776" cy="4882896"/>
+          </a:xfrm>
+          <a:prstGeom prst="rect">
+            <a:avLst/>
+          </a:prstGeom>
+          <a:noFill/>
+        </p:spPr>
+        <p:txBody>
+          <a:bodyPr wrap="square">
+            <a:spAutoFit/>
+          </a:bodyPr>
+          <a:lstStyle/>
+          <a:p/>
+          <a:p>
+            <a:pPr algn="l">
+              <a:spcBef>
+                <a:spcPts val="0"/>
+              </a:spcBef>
+              <a:spcAft>
+                <a:spcPts val="800"/>
+              </a:spcAft>
+              <a:defRPr sz="1400" b="1" i="0">
+                <a:solidFill>
+                  <a:srgbClr val="F59E0B"/>
+                </a:solidFill>
+                <a:latin typeface="Arial"/>
+              </a:defRPr>
+            </a:pPr>
+            <a:r>
+              <a:t>El Problema de BLEU (Palabra Completa)</a:t>
+            </a:r>
+          </a:p>
+          <a:p>
+            <a:pPr algn="l">
+              <a:spcBef>
+                <a:spcPts val="0"/>
+              </a:spcBef>
+              <a:spcAft>
+                <a:spcPts val="600"/>
+              </a:spcAft>
+              <a:defRPr sz="1150" b="0" i="0">
+                <a:solidFill>
+                  <a:srgbClr val="FFFFFF"/>
+                </a:solidFill>
+                <a:latin typeface="Arial"/>
+              </a:defRPr>
+            </a:pPr>
+            <a:r>
+              <a:t>• BLEU (Bilingual Evaluation Understudy) evalúa precisión exacta a nivel de palabra completa.</a:t>
+            </a:r>
+          </a:p>
+          <a:p>
+            <a:pPr algn="l">
+              <a:spcBef>
+                <a:spcPts val="0"/>
+              </a:spcBef>
+              <a:spcAft>
+                <a:spcPts val="600"/>
+              </a:spcAft>
+              <a:defRPr sz="1150" b="0" i="0">
+                <a:solidFill>
+                  <a:srgbClr val="FFFFFF"/>
+                </a:solidFill>
+                <a:latin typeface="Arial"/>
+              </a:defRPr>
+            </a:pPr>
+            <a:r>
+              <a:t>• En idiomas aglutinantes, omitir o errar un solo sufijo al final de una palabra larga (por ejemplo, el sufijo enfático '-wa') provoca que BLEU clasifique la palabra completa como 100% incorrecta.</a:t>
+            </a:r>
+          </a:p>
+          <a:p>
+            <a:pPr algn="l">
+              <a:spcBef>
+                <a:spcPts val="0"/>
+              </a:spcBef>
+              <a:spcAft>
+                <a:spcPts val="600"/>
+              </a:spcAft>
+              <a:defRPr sz="1150" b="0" i="0">
+                <a:solidFill>
+                  <a:srgbClr val="FFFFFF"/>
+                </a:solidFill>
+                <a:latin typeface="Arial"/>
+              </a:defRPr>
+            </a:pPr>
+            <a:r>
+              <a:t>• Esto causa una subestimación crítica de la calidad real de los traductores automáticos neuronales.</a:t>
+            </a:r>
+          </a:p>
+        </p:txBody>
+      </p:sp>
+      <p:sp>
+        <p:nvSpPr>
+          <p:cNvPr id="8" name="Rectangle 7"/>
+          <p:cNvSpPr/>
+          <p:nvPr/>
+        </p:nvSpPr>
+        <p:spPr>
+          <a:xfrm>
+            <a:off x="6428232" y="1188720"/>
+            <a:ext cx="5394960" cy="5212080"/>
+          </a:xfrm>
+          <a:prstGeom prst="rect">
+            <a:avLst/>
+          </a:prstGeom>
+          <a:solidFill>
+            <a:srgbClr val="121626"/>
+          </a:solidFill>
+          <a:ln w="12700">
+            <a:solidFill>
+              <a:srgbClr val="1E293B"/>
+            </a:solidFill>
+          </a:ln>
+        </p:spPr>
+        <p:style>
+          <a:lnRef idx="1">
+            <a:schemeClr val="accent1"/>
+          </a:lnRef>
+          <a:fillRef idx="3">
+            <a:schemeClr val="accent1"/>
+          </a:fillRef>
+          <a:effectRef idx="2">
+            <a:schemeClr val="accent1"/>
+          </a:effectRef>
+          <a:fontRef idx="minor">
+            <a:schemeClr val="lt1"/>
+          </a:fontRef>
+        </p:style>
+        <p:txBody>
+          <a:bodyPr rtlCol="0" anchor="ctr"/>
+          <a:lstStyle/>
+          <a:p>
+            <a:pPr algn="ctr"/>
+          </a:p>
+        </p:txBody>
+      </p:sp>
+      <p:sp>
+        <p:nvSpPr>
+          <p:cNvPr id="9" name="TextBox 8"/>
+          <p:cNvSpPr txBox="1"/>
+          <p:nvPr/>
+        </p:nvSpPr>
+        <p:spPr>
+          <a:xfrm>
+            <a:off x="6592824" y="1353312"/>
+            <a:ext cx="5065776" cy="4882896"/>
+          </a:xfrm>
+          <a:prstGeom prst="rect">
+            <a:avLst/>
+          </a:prstGeom>
+          <a:noFill/>
+        </p:spPr>
+        <p:txBody>
+          <a:bodyPr wrap="square">
+            <a:spAutoFit/>
+          </a:bodyPr>
+          <a:lstStyle/>
+          <a:p/>
+          <a:p>
+            <a:pPr algn="l">
+              <a:spcBef>
+                <a:spcPts val="0"/>
+              </a:spcBef>
+              <a:spcAft>
+                <a:spcPts val="800"/>
+              </a:spcAft>
+              <a:defRPr sz="1400" b="1" i="0">
+                <a:solidFill>
+                  <a:srgbClr val="10B981"/>
+                </a:solidFill>
+                <a:latin typeface="Arial"/>
+              </a:defRPr>
+            </a:pPr>
+            <a:r>
+              <a:t>La Solución Científica: ChrF++</a:t>
+            </a:r>
+          </a:p>
+          <a:p>
+            <a:pPr algn="l">
+              <a:spcBef>
+                <a:spcPts val="0"/>
+              </a:spcBef>
+              <a:spcAft>
+                <a:spcPts val="600"/>
+              </a:spcAft>
+              <a:defRPr sz="1150" b="0" i="0">
+                <a:solidFill>
+                  <a:srgbClr val="FFFFFF"/>
+                </a:solidFill>
+                <a:latin typeface="Arial"/>
+              </a:defRPr>
+            </a:pPr>
+            <a:r>
+              <a:t>• ChrF++ extrae y compara n-gramas de caracteres además de palabras completas.</a:t>
+            </a:r>
+          </a:p>
+          <a:p>
+            <a:pPr algn="l">
+              <a:spcBef>
+                <a:spcPts val="0"/>
+              </a:spcBef>
+              <a:spcAft>
+                <a:spcPts val="600"/>
+              </a:spcAft>
+              <a:defRPr sz="1150" b="0" i="0">
+                <a:solidFill>
+                  <a:srgbClr val="FFFFFF"/>
+                </a:solidFill>
+                <a:latin typeface="Arial"/>
+              </a:defRPr>
+            </a:pPr>
+            <a:r>
+              <a:t>• Si el modelo traduce de manera morfológicamente coherente la raíz del verbo pero falla levemente en el sufijo, ChrF++ premia la coincidencia morfológica parcial.</a:t>
+            </a:r>
+          </a:p>
+          <a:p>
+            <a:pPr algn="l">
+              <a:spcBef>
+                <a:spcPts val="0"/>
+              </a:spcBef>
+              <a:spcAft>
+                <a:spcPts val="600"/>
+              </a:spcAft>
+              <a:defRPr sz="1150" b="0" i="0">
+                <a:solidFill>
+                  <a:srgbClr val="FFFFFF"/>
+                </a:solidFill>
+                <a:latin typeface="Arial"/>
+              </a:defRPr>
+            </a:pPr>
+            <a:r>
+              <a:t>• Es la métrica recomendada por la comunidad científica (WMT, AmericasNLP) para evaluar con rigurosidad y justicia las lenguas originarias de las Américas.</a:t>
+            </a:r>
+          </a:p>
+        </p:txBody>
+      </p:sp>
+    </p:spTree>
+  </p:cSld>
+  <p:clrMapOvr>
+    <a:masterClrMapping/>
+  </p:clrMapOvr>
+</p:sld>
+</file>
+
+<file path=ppt/slides/slide13.xml><?xml version="1.0" encoding="utf-8"?>
+<p:sld xmlns:a="http://schemas.openxmlformats.org/drawingml/2006/main" xmlns:p="http://schemas.openxmlformats.org/presentationml/2006/main" xmlns:r="http://schemas.openxmlformats.org/officeDocument/2006/relationships">
+  <p:cSld>
+    <p:bg>
+      <p:bgPr>
+        <a:solidFill>
+          <a:srgbClr val="0A0C16"/>
+        </a:solidFill>
+        <a:effectLst/>
+      </p:bgPr>
+    </p:bg>
+    <p:spTree>
+      <p:nvGrpSpPr>
+        <p:cNvPr id="1" name=""/>
+        <p:cNvGrpSpPr/>
+        <p:nvPr/>
+      </p:nvGrpSpPr>
+      <p:grpSpPr/>
+      <p:sp>
+        <p:nvSpPr>
+          <p:cNvPr id="2" name="Rectangle 1"/>
+          <p:cNvSpPr/>
+          <p:nvPr/>
+        </p:nvSpPr>
+        <p:spPr>
+          <a:xfrm>
+            <a:off x="0" y="0"/>
+            <a:ext cx="12188952" cy="82296"/>
+          </a:xfrm>
+          <a:prstGeom prst="rect">
+            <a:avLst/>
+          </a:prstGeom>
+          <a:solidFill>
+            <a:srgbClr val="10B981"/>
+          </a:solidFill>
+          <a:ln>
+            <a:noFill/>
+          </a:ln>
+        </p:spPr>
+        <p:style>
+          <a:lnRef idx="1">
+            <a:schemeClr val="accent1"/>
+          </a:lnRef>
+          <a:fillRef idx="3">
+            <a:schemeClr val="accent1"/>
+          </a:fillRef>
+          <a:effectRef idx="2">
+            <a:schemeClr val="accent1"/>
+          </a:effectRef>
+          <a:fontRef idx="minor">
+            <a:schemeClr val="lt1"/>
+          </a:fontRef>
+        </p:style>
+        <p:txBody>
+          <a:bodyPr rtlCol="0" anchor="ctr"/>
+          <a:lstStyle/>
+          <a:p>
+            <a:pPr algn="ctr"/>
+          </a:p>
+        </p:txBody>
+      </p:sp>
+      <p:sp>
+        <p:nvSpPr>
+          <p:cNvPr id="3" name="Rectangle 2"/>
+          <p:cNvSpPr/>
+          <p:nvPr/>
+        </p:nvSpPr>
+        <p:spPr>
+          <a:xfrm>
+            <a:off x="0" y="6793992"/>
+            <a:ext cx="12188952" cy="64008"/>
+          </a:xfrm>
+          <a:prstGeom prst="rect">
+            <a:avLst/>
+          </a:prstGeom>
+          <a:solidFill>
+            <a:srgbClr val="1E293B"/>
+          </a:solidFill>
+          <a:ln>
+            <a:noFill/>
+          </a:ln>
+        </p:spPr>
+        <p:style>
+          <a:lnRef idx="1">
+            <a:schemeClr val="accent1"/>
+          </a:lnRef>
+          <a:fillRef idx="3">
+            <a:schemeClr val="accent1"/>
+          </a:fillRef>
+          <a:effectRef idx="2">
+            <a:schemeClr val="accent1"/>
+          </a:effectRef>
+          <a:fontRef idx="minor">
+            <a:schemeClr val="lt1"/>
+          </a:fontRef>
+        </p:style>
+        <p:txBody>
+          <a:bodyPr rtlCol="0" anchor="ctr"/>
+          <a:lstStyle/>
+          <a:p>
+            <a:pPr algn="ctr"/>
+          </a:p>
+        </p:txBody>
+      </p:sp>
+      <p:sp>
+        <p:nvSpPr>
+          <p:cNvPr id="4" name="TextBox 3"/>
+          <p:cNvSpPr txBox="1"/>
+          <p:nvPr/>
+        </p:nvSpPr>
+        <p:spPr>
+          <a:xfrm>
+            <a:off x="11430000" y="6537960"/>
+            <a:ext cx="731520" cy="274320"/>
+          </a:xfrm>
+          <a:prstGeom prst="rect">
+            <a:avLst/>
+          </a:prstGeom>
+          <a:noFill/>
+        </p:spPr>
+        <p:txBody>
+          <a:bodyPr wrap="none">
+            <a:spAutoFit/>
+          </a:bodyPr>
+          <a:lstStyle/>
+          <a:p/>
+          <a:p>
+            <a:pPr algn="r">
+              <a:spcBef>
+                <a:spcPts val="0"/>
+              </a:spcBef>
+              <a:spcAft>
+                <a:spcPts val="600"/>
+              </a:spcAft>
+              <a:defRPr sz="800" b="0" i="0">
+                <a:solidFill>
+                  <a:srgbClr val="94A3B8"/>
+                </a:solidFill>
+                <a:latin typeface="Arial"/>
+              </a:defRPr>
+            </a:pPr>
+            <a:r>
+              <a:t>13 / 13</a:t>
+            </a:r>
+          </a:p>
+        </p:txBody>
+      </p:sp>
+      <p:sp>
+        <p:nvSpPr>
+          <p:cNvPr id="5" name="Rectangle 4"/>
+          <p:cNvSpPr/>
+          <p:nvPr/>
+        </p:nvSpPr>
+        <p:spPr>
+          <a:xfrm>
+            <a:off x="685800" y="731520"/>
+            <a:ext cx="10817352" cy="5303520"/>
+          </a:xfrm>
+          <a:prstGeom prst="rect">
+            <a:avLst/>
+          </a:prstGeom>
+          <a:solidFill>
+            <a:srgbClr val="121626"/>
+          </a:solidFill>
+          <a:ln w="12700">
+            <a:solidFill>
+              <a:srgbClr val="10B981"/>
+            </a:solidFill>
+          </a:ln>
+        </p:spPr>
+        <p:style>
+          <a:lnRef idx="1">
+            <a:schemeClr val="accent1"/>
+          </a:lnRef>
+          <a:fillRef idx="3">
+            <a:schemeClr val="accent1"/>
+          </a:fillRef>
+          <a:effectRef idx="2">
+            <a:schemeClr val="accent1"/>
+          </a:effectRef>
+          <a:fontRef idx="minor">
+            <a:schemeClr val="lt1"/>
+          </a:fontRef>
+        </p:style>
+        <p:txBody>
+          <a:bodyPr rtlCol="0" anchor="ctr"/>
+          <a:lstStyle/>
+          <a:p>
+            <a:pPr algn="ctr"/>
+          </a:p>
+        </p:txBody>
+      </p:sp>
+      <p:sp>
+        <p:nvSpPr>
+          <p:cNvPr id="6" name="TextBox 5"/>
+          <p:cNvSpPr txBox="1"/>
+          <p:nvPr/>
+        </p:nvSpPr>
+        <p:spPr>
+          <a:xfrm>
+            <a:off x="1005840" y="1005840"/>
+            <a:ext cx="10149840" cy="4937760"/>
+          </a:xfrm>
+          <a:prstGeom prst="rect">
+            <a:avLst/>
+          </a:prstGeom>
+          <a:noFill/>
+        </p:spPr>
+        <p:txBody>
+          <a:bodyPr wrap="square">
+            <a:spAutoFit/>
+          </a:bodyPr>
+          <a:lstStyle/>
+          <a:p/>
+          <a:p>
+            <a:pPr algn="l">
+              <a:spcBef>
+                <a:spcPts val="0"/>
+              </a:spcBef>
+              <a:spcAft>
+                <a:spcPts val="400"/>
+              </a:spcAft>
+              <a:defRPr sz="850" b="1" i="0">
+                <a:solidFill>
+                  <a:srgbClr val="10B981"/>
+                </a:solidFill>
+                <a:latin typeface="Arial"/>
+              </a:defRPr>
+            </a:pPr>
+            <a:r>
+              <a:t>CONCLUSIONES ACADÉMICAS</a:t>
+            </a:r>
+          </a:p>
+          <a:p>
+            <a:pPr algn="l">
+              <a:spcBef>
+                <a:spcPts val="0"/>
+              </a:spcBef>
+              <a:spcAft>
+                <a:spcPts val="800"/>
+              </a:spcAft>
+              <a:defRPr sz="2400" b="1" i="0">
+                <a:solidFill>
+                  <a:srgbClr val="FFFFFF"/>
+                </a:solidFill>
+                <a:latin typeface="Arial"/>
+              </a:defRPr>
+            </a:pPr>
+            <a:r>
+              <a:t>Conclusiones y Líneas de Investigación Futura</a:t>
+            </a:r>
+          </a:p>
+          <a:p>
+            <a:pPr algn="l">
+              <a:spcBef>
+                <a:spcPts val="0"/>
+              </a:spcBef>
+              <a:spcAft>
+                <a:spcPts val="400"/>
+              </a:spcAft>
+              <a:defRPr sz="700" b="0" i="0">
+                <a:solidFill>
+                  <a:srgbClr val="94A3B8"/>
+                </a:solidFill>
+                <a:latin typeface="Arial"/>
+              </a:defRPr>
+            </a:pPr>
+            <a:r>
+              <a:t>────────────────────────────────────────────────────────────────────</a:t>
+            </a:r>
+          </a:p>
+          <a:p>
+            <a:pPr algn="l">
+              <a:spcBef>
+                <a:spcPts val="0"/>
+              </a:spcBef>
+              <a:spcAft>
+                <a:spcPts val="600"/>
+              </a:spcAft>
+              <a:defRPr sz="1150" b="0" i="0">
+                <a:solidFill>
+                  <a:srgbClr val="FFFFFF"/>
+                </a:solidFill>
+                <a:latin typeface="Arial"/>
+              </a:defRPr>
+            </a:pPr>
+            <a:r>
+              <a:t>• ✓ Superioridad de SentencePiece: El pre-entrenamiento de SentencePiece especializado en NLLB-200 supera drásticamente a los tokenizadores BPE generales de LLMs masivos en lenguas aglutinantes.</a:t>
+            </a:r>
+          </a:p>
+          <a:p>
+            <a:pPr algn="l">
+              <a:spcBef>
+                <a:spcPts val="0"/>
+              </a:spcBef>
+              <a:spcAft>
+                <a:spcPts val="600"/>
+              </a:spcAft>
+              <a:defRPr sz="1150" b="0" i="0">
+                <a:solidFill>
+                  <a:srgbClr val="FFFFFF"/>
+                </a:solidFill>
+                <a:latin typeface="Arial"/>
+              </a:defRPr>
+            </a:pPr>
+            <a:r>
+              <a:t>• ✓ Preservación Morfológica: Minimizar la fragmentación a nivel de raíz y sufijo es indispensable para optimizar la ventana de atención y acelerar la convergencia semántica en la GPU local.</a:t>
+            </a:r>
+          </a:p>
+          <a:p>
+            <a:pPr algn="l">
+              <a:spcBef>
+                <a:spcPts val="0"/>
+              </a:spcBef>
+              <a:spcAft>
+                <a:spcPts val="600"/>
+              </a:spcAft>
+              <a:defRPr sz="1150" b="0" i="0">
+                <a:solidFill>
+                  <a:srgbClr val="FFFFFF"/>
+                </a:solidFill>
+                <a:latin typeface="Arial"/>
+              </a:defRPr>
+            </a:pPr>
+            <a:r>
+              <a:t>• ✓ Viabilidad Local en RTX 5060: El fine-tuning eficiente mediante adaptadores de bajo rango (LoRA) permite una flexibilidad SOTA con solo ~18 MB de adaptadores independientes del modelo base.</a:t>
+            </a:r>
+          </a:p>
+          <a:p>
+            <a:pPr algn="l">
+              <a:spcBef>
+                <a:spcPts val="0"/>
+              </a:spcBef>
+              <a:spcAft>
+                <a:spcPts val="400"/>
+              </a:spcAft>
+              <a:defRPr sz="700" b="0" i="0">
+                <a:solidFill>
+                  <a:srgbClr val="94A3B8"/>
+                </a:solidFill>
+                <a:latin typeface="Arial"/>
+              </a:defRPr>
+            </a:pPr>
+            <a:r>
+              <a:t>────────────────────────────────────────────────────────────────────</a:t>
+            </a:r>
+          </a:p>
+          <a:p>
+            <a:pPr algn="l">
+              <a:spcBef>
+                <a:spcPts val="0"/>
+              </a:spcBef>
+              <a:spcAft>
+                <a:spcPts val="800"/>
+              </a:spcAft>
+              <a:defRPr sz="1500" b="1" i="0">
+                <a:solidFill>
+                  <a:srgbClr val="8B5CF6"/>
+                </a:solidFill>
+                <a:latin typeface="Arial"/>
+              </a:defRPr>
+            </a:pPr>
+            <a:r>
+              <a:t>Trabajo Futuro</a:t>
+            </a:r>
+          </a:p>
+          <a:p>
+            <a:pPr algn="l">
+              <a:spcBef>
+                <a:spcPts val="0"/>
+              </a:spcBef>
+              <a:spcAft>
+                <a:spcPts val="600"/>
+              </a:spcAft>
+              <a:defRPr sz="1150" b="0" i="0">
+                <a:solidFill>
+                  <a:srgbClr val="FFFFFF"/>
+                </a:solidFill>
+                <a:latin typeface="Arial"/>
+              </a:defRPr>
+            </a:pPr>
+            <a:r>
+              <a:t>• • Desarrollar un tokenizador SentencePiece híbrido morfológico supervisado por lingüistas aimaras.</a:t>
+            </a:r>
+          </a:p>
+          <a:p>
+            <a:pPr algn="l">
+              <a:spcBef>
+                <a:spcPts val="0"/>
+              </a:spcBef>
+              <a:spcAft>
+                <a:spcPts val="600"/>
+              </a:spcAft>
+              <a:defRPr sz="1150" b="0" i="0">
+                <a:solidFill>
+                  <a:srgbClr val="FFFFFF"/>
+                </a:solidFill>
+                <a:latin typeface="Arial"/>
+              </a:defRPr>
+            </a:pPr>
+            <a:r>
+              <a:t>• • Implementar pipelines Speech-to-Speech offline mediante cuantización Q4_K_M ejecutables en dispositivos periféricos y móviles.</a:t>
+            </a:r>
+          </a:p>
+        </p:txBody>
+      </p:sp>
+    </p:spTree>
+  </p:cSld>
+  <p:clrMapOvr>
+    <a:masterClrMapping/>
+  </p:clrMapOvr>
+</p:sld>
+</file>
+
 <file path=ppt/slides/slide2.xml><?xml version="1.0" encoding="utf-8"?>
 <p:sld xmlns:a="http://schemas.openxmlformats.org/drawingml/2006/main" xmlns:p="http://schemas.openxmlformats.org/presentationml/2006/main" xmlns:r="http://schemas.openxmlformats.org/officeDocument/2006/relationships">
   <p:cSld>
@@ -3642,7 +5377,7 @@
               </a:defRPr>
             </a:pPr>
             <a:r>
-              <a:t>2 / 9</a:t>
+              <a:t>2 / 13</a:t>
             </a:r>
           </a:p>
         </p:txBody>
@@ -3685,7 +5420,7 @@
               </a:defRPr>
             </a:pPr>
             <a:r>
-              <a:t>MORFOLOGÍA DE LENGUAS ORIGINARIAS</a:t>
+              <a:t>FASE 1 DEL PIPELINE NMT</a:t>
             </a:r>
           </a:p>
           <a:p>
@@ -3704,7 +5439,7 @@
               </a:defRPr>
             </a:pPr>
             <a:r>
-              <a:t>El Desafío Lingüístico: Morfología Aglutinante en Aimara</a:t>
+              <a:t>El Corpus Paralelo: El Cimiento de la Traducción Automática</a:t>
             </a:r>
           </a:p>
         </p:txBody>
@@ -3792,7 +5527,7 @@
               </a:defRPr>
             </a:pPr>
             <a:r>
-              <a:t>Estructura Sintética Extrema</a:t>
+              <a:t>Alineación de Textos Paralelos</a:t>
             </a:r>
           </a:p>
           <a:p>
@@ -3811,7 +5546,7 @@
               </a:defRPr>
             </a:pPr>
             <a:r>
-              <a:t>• A diferencia de las lenguas indoeuropeas (como el Español) donde las palabras se dividen limpiamente por espacios, el Aimara es una lengua polisintética y aglutinante.</a:t>
+              <a:t>• Un corpus paralelo consiste en un conjunto de pares de oraciones paralelas traducidas y alineadas exactamente línea por línea.</a:t>
             </a:r>
           </a:p>
           <a:p>
@@ -3830,7 +5565,7 @@
               </a:defRPr>
             </a:pPr>
             <a:r>
-              <a:t>• Las oraciones y conceptos sumamente complejos se construyen a partir de una raíz léxica a la cual se le añade en serie una cadena de múltiples morfemas (sufijos).</a:t>
+              <a:t>• Para este proyecto, se utilizó el corpus de la ponencia AmericasNLP (Español ⇄ Aimara Central), que contiene expresiones de dominio general, gubernamental y salud.</a:t>
             </a:r>
           </a:p>
           <a:p>
@@ -3849,7 +5584,7 @@
               </a:defRPr>
             </a:pPr>
             <a:r>
-              <a:t>• Esto causa dispersión de vocabulario severa: una misma raíz nominal o verbal puede dar lugar a millones de formas flexivas únicas, haciendo inviable un vocabulario a nivel de palabra.</a:t>
+              <a:t>• El cimiento de la calidad del modelo seq2seq recae en la consistencia gramatical y léxica de estas alineaciones.</a:t>
             </a:r>
           </a:p>
         </p:txBody>
@@ -3937,7 +5672,7 @@
               </a:defRPr>
             </a:pPr>
             <a:r>
-              <a:t>Análisis de Caso Insignia</a:t>
+              <a:t>Preprocesamiento y Calidad (QA)</a:t>
             </a:r>
           </a:p>
           <a:p>
@@ -3948,129 +5683,72 @@
               <a:spcAft>
                 <a:spcPts val="600"/>
               </a:spcAft>
+              <a:defRPr sz="1150" b="0" i="0">
+                <a:solidFill>
+                  <a:srgbClr val="FFFFFF"/>
+                </a:solidFill>
+                <a:latin typeface="Arial"/>
+              </a:defRPr>
+            </a:pPr>
+            <a:r>
+              <a:t>• Control de Calidad Riguroso: Eliminación de pares duplicados, líneas vacías y oraciones desalineadas.</a:t>
+            </a:r>
+          </a:p>
+          <a:p>
+            <a:pPr algn="l">
+              <a:spcBef>
+                <a:spcPts val="0"/>
+              </a:spcBef>
+              <a:spcAft>
+                <a:spcPts val="600"/>
+              </a:spcAft>
+              <a:defRPr sz="1150" b="0" i="0">
+                <a:solidFill>
+                  <a:srgbClr val="FFFFFF"/>
+                </a:solidFill>
+                <a:latin typeface="Arial"/>
+              </a:defRPr>
+            </a:pPr>
+            <a:r>
+              <a:t>• Filtro de Ratio de Longitud Extremo: Se descartaron frases donde:</a:t>
+            </a:r>
+          </a:p>
+          <a:p>
+            <a:pPr algn="ctr">
+              <a:spcBef>
+                <a:spcPts val="0"/>
+              </a:spcBef>
+              <a:spcAft>
+                <a:spcPts val="800"/>
+              </a:spcAft>
               <a:defRPr sz="1200" b="1" i="0">
                 <a:solidFill>
+                  <a:srgbClr val="F59E0B"/>
+                </a:solidFill>
+                <a:latin typeface="Arial"/>
+              </a:defRPr>
+            </a:pPr>
+            <a:r>
+              <a:t>0.25 &lt; (Largo_ES / Largo_AYM) &lt; 4.0</a:t>
+            </a:r>
+          </a:p>
+          <a:p>
+            <a:pPr algn="l">
+              <a:spcBef>
+                <a:spcPts val="0"/>
+              </a:spcBef>
+              <a:spcAft>
+                <a:spcPts val="600"/>
+              </a:spcAft>
+              <a:defRPr sz="1150" b="0" i="0">
+                <a:solidFill>
                   <a:srgbClr val="FFFFFF"/>
                 </a:solidFill>
                 <a:latin typeface="Arial"/>
               </a:defRPr>
             </a:pPr>
             <a:r>
-              <a:t>Palabra aglutinante extrema en Aimara:</a:t>
-            </a:r>
-          </a:p>
-          <a:p>
-            <a:pPr algn="ctr">
-              <a:spcBef>
-                <a:spcPts val="500"/>
-              </a:spcBef>
-              <a:spcAft>
-                <a:spcPts val="1000"/>
-              </a:spcAft>
-              <a:defRPr sz="1500" b="1" i="0">
-                <a:solidFill>
-                  <a:srgbClr val="F59E0B"/>
-                </a:solidFill>
-                <a:latin typeface="Arial"/>
-              </a:defRPr>
-            </a:pPr>
-            <a:r>
-              <a:t>aruskipapxañanakasakipunirakispawa</a:t>
-            </a:r>
-          </a:p>
-          <a:p>
-            <a:pPr algn="l">
-              <a:spcBef>
-                <a:spcPts val="0"/>
-              </a:spcBef>
-              <a:spcAft>
-                <a:spcPts val="600"/>
-              </a:spcAft>
-              <a:defRPr sz="1100" b="1" i="0">
-                <a:solidFill>
-                  <a:srgbClr val="94A3B8"/>
-                </a:solidFill>
-                <a:latin typeface="Arial"/>
-              </a:defRPr>
-            </a:pPr>
-            <a:r>
-              <a:t>Traducción humana exacta al Español:</a:t>
-            </a:r>
-          </a:p>
-          <a:p>
-            <a:pPr algn="ctr">
-              <a:spcBef>
-                <a:spcPts val="0"/>
-              </a:spcBef>
-              <a:spcAft>
-                <a:spcPts val="1500"/>
-              </a:spcAft>
-              <a:defRPr sz="1200" b="0" i="1">
-                <a:solidFill>
-                  <a:srgbClr val="FFFFFF"/>
-                </a:solidFill>
-                <a:latin typeface="Arial"/>
-              </a:defRPr>
-            </a:pPr>
-            <a:r>
-              <a:t>"Es una obligación mutua hablar entre nosotros de forma ineludible."</a:t>
-            </a:r>
-          </a:p>
-          <a:p>
-            <a:pPr algn="l">
-              <a:spcBef>
-                <a:spcPts val="0"/>
-              </a:spcBef>
-              <a:spcAft>
-                <a:spcPts val="400"/>
-              </a:spcAft>
-              <a:defRPr sz="700" b="0" i="0">
-                <a:solidFill>
-                  <a:srgbClr val="94A3B8"/>
-                </a:solidFill>
-                <a:latin typeface="Arial"/>
-              </a:defRPr>
-            </a:pPr>
-            <a:r>
-              <a:t>────────────────────────────────────────────────────────────────────</a:t>
-            </a:r>
-          </a:p>
-          <a:p>
-            <a:pPr algn="l">
-              <a:spcBef>
-                <a:spcPts val="0"/>
-              </a:spcBef>
-              <a:spcAft>
-                <a:spcPts val="600"/>
-              </a:spcAft>
-              <a:defRPr sz="1150" b="0" i="0">
-                <a:solidFill>
-                  <a:srgbClr val="FFFFFF"/>
-                </a:solidFill>
-                <a:latin typeface="Arial"/>
-              </a:defRPr>
-            </a:pPr>
-            <a:r>
-              <a:t>• Si alimentamos al Transformer con palabras enteras, el modelo sufrirá colapso por palabras fuera de vocabulario (OOV).</a:t>
-            </a:r>
-          </a:p>
-          <a:p>
-            <a:pPr algn="l">
-              <a:spcBef>
-                <a:spcPts val="0"/>
-              </a:spcBef>
-              <a:spcAft>
-                <a:spcPts val="600"/>
-              </a:spcAft>
-              <a:defRPr sz="1150" b="0" i="0">
-                <a:solidFill>
-                  <a:srgbClr val="FFFFFF"/>
-                </a:solidFill>
-                <a:latin typeface="Arial"/>
-              </a:defRPr>
-            </a:pPr>
-            <a:r>
-              <a:t>• Se requiere obligatoriamente segmentar a nivel de subpalabras (subwords) para que la red capture la raíz y los morfemas por separado.</a:t>
+              <a:t>• Esto previene que el Transformer intente mapear conceptos dispares o vacíos, optimizando la pérdida durante el entrenamiento.</a:t>
             </a:r>
           </a:p>
         </p:txBody>
@@ -4225,7 +5903,7 @@
               </a:defRPr>
             </a:pPr>
             <a:r>
-              <a:t>3 / 9</a:t>
+              <a:t>3 / 13</a:t>
             </a:r>
           </a:p>
         </p:txBody>
@@ -4268,7 +5946,7 @@
               </a:defRPr>
             </a:pPr>
             <a:r>
-              <a:t>ARQUITECTURA DE TOKENIZADORES</a:t>
+              <a:t>FASE 2 DEL PIPELINE NMT</a:t>
             </a:r>
           </a:p>
           <a:p>
@@ -4287,7 +5965,7 @@
               </a:defRPr>
             </a:pPr>
             <a:r>
-              <a:t>Por qué la Tokenización define el Rendimiento del NMT</a:t>
+              <a:t>La Tokenización: Segmentación y Mapeo Numérico</a:t>
             </a:r>
           </a:p>
         </p:txBody>
@@ -4375,7 +6053,7 @@
               </a:defRPr>
             </a:pPr>
             <a:r>
-              <a:t>El Dilema del Vocabulario Abierto</a:t>
+              <a:t>Algoritmos de Subpalabras (Subwords)</a:t>
             </a:r>
           </a:p>
           <a:p>
@@ -4394,7 +6072,7 @@
               </a:defRPr>
             </a:pPr>
             <a:r>
-              <a:t>• La tokenización actúa como las 'tijeras' de la red neuronal. Convierte caracteres en IDs numéricos indexados en una matriz de embeddings.</a:t>
+              <a:t>• SentencePiece (Kudo et al., 2018): Trata el texto como una secuencia de caracteres (sin depender de espacios) y aprende subpalabras flexibles utilizando modelos de unigrama o BPE.</a:t>
             </a:r>
           </a:p>
           <a:p>
@@ -4413,7 +6091,7 @@
               </a:defRPr>
             </a:pPr>
             <a:r>
-              <a:t>• Si cortamos muy poco (palabras enteras): El vocabulario explota y el modelo no puede generalizar a palabras no vistas durante el entrenamiento.</a:t>
+              <a:t>• Byte-Pair Encoding (BPE): Une iterativamente pares de bytes o caracteres más frecuentes para formar un vocabulario compacto.</a:t>
             </a:r>
           </a:p>
           <a:p>
@@ -4432,26 +6110,7 @@
               </a:defRPr>
             </a:pPr>
             <a:r>
-              <a:t>• Si cortamos en exceso (letras individuales): La secuencia se vuelve extremadamente larga, erosionando y colapsando la ventana de auto-atención del Transformer.</a:t>
-            </a:r>
-          </a:p>
-          <a:p>
-            <a:pPr algn="l">
-              <a:spcBef>
-                <a:spcPts val="0"/>
-              </a:spcBef>
-              <a:spcAft>
-                <a:spcPts val="600"/>
-              </a:spcAft>
-              <a:defRPr sz="1150" b="0" i="0">
-                <a:solidFill>
-                  <a:srgbClr val="FFFFFF"/>
-                </a:solidFill>
-                <a:latin typeface="Arial"/>
-              </a:defRPr>
-            </a:pPr>
-            <a:r>
-              <a:t>• Segmentación de Subpalabras (Subword Tokenization): Busca el equilibrio óptimo de entropía, segmentando en unidades semánticamente cohesivas.</a:t>
+              <a:t>• El tokenizador aísla las flexiones gramaticales (como el sufijo -wa o -naka en Aimara) y las almacena como elementos individuales.</a:t>
             </a:r>
           </a:p>
         </p:txBody>
@@ -4539,7 +6198,7 @@
               </a:defRPr>
             </a:pPr>
             <a:r>
-              <a:t>Impacto en la Atención de la GPU</a:t>
+              <a:t>Mapeo a Token IDs (Discretos)</a:t>
             </a:r>
           </a:p>
           <a:p>
@@ -4558,7 +6217,26 @@
               </a:defRPr>
             </a:pPr>
             <a:r>
-              <a:t>• En lenguas aglutinantes, la sobrefragmentación morfológica causa que palabras cortas se segmenten en decenas de micro-tokens sin significado.</a:t>
+              <a:t>• Una vez que la frase se divide en subpalabras (tokens), cada token se asocia de forma determinista con un número entero único (Token ID) en base al índice del vocabulario.</a:t>
+            </a:r>
+          </a:p>
+          <a:p>
+            <a:pPr algn="ctr">
+              <a:spcBef>
+                <a:spcPts val="0"/>
+              </a:spcBef>
+              <a:spcAft>
+                <a:spcPts val="1000"/>
+              </a:spcAft>
+              <a:defRPr sz="1100" b="1" i="0">
+                <a:solidFill>
+                  <a:srgbClr val="F59E0B"/>
+                </a:solidFill>
+                <a:latin typeface="Arial"/>
+              </a:defRPr>
+            </a:pPr>
+            <a:r>
+              <a:t>"kamisaraki" ➔ ["kamis", "araki"] ➔ [4562, 12903]</a:t>
             </a:r>
           </a:p>
           <a:p>
@@ -4577,26 +6255,7 @@
               </a:defRPr>
             </a:pPr>
             <a:r>
-              <a:t>• Esto diluye la representación semántica en el vector espacial de embeddings y sobrecarga innecesariamente el mecanismo de Multi-Head Attention del Transformer.</a:t>
-            </a:r>
-          </a:p>
-          <a:p>
-            <a:pPr algn="l">
-              <a:spcBef>
-                <a:spcPts val="0"/>
-              </a:spcBef>
-              <a:spcAft>
-                <a:spcPts val="600"/>
-              </a:spcAft>
-              <a:defRPr sz="1150" b="0" i="0">
-                <a:solidFill>
-                  <a:srgbClr val="FFFFFF"/>
-                </a:solidFill>
-                <a:latin typeface="Arial"/>
-              </a:defRPr>
-            </a:pPr>
-            <a:r>
-              <a:t>• Un tokenizador especializado debe capturar y mantener las raíces léxicas y aislar los sufijos gramaticales completos de forma morfológicamente coherente.</a:t>
+              <a:t>• El vocabulario de NLLB-200 tiene 256,206 índices únicos, lo que le permite representar oraciones complejas de forma compacta y eficiente.</a:t>
             </a:r>
           </a:p>
         </p:txBody>
@@ -4751,7 +6410,7 @@
               </a:defRPr>
             </a:pPr>
             <a:r>
-              <a:t>4 / 9</a:t>
+              <a:t>4 / 13</a:t>
             </a:r>
           </a:p>
         </p:txBody>
@@ -4794,7 +6453,7 @@
               </a:defRPr>
             </a:pPr>
             <a:r>
-              <a:t>ARENA DE COMPARACIÓN DE IA</a:t>
+              <a:t>FASE 3 DEL PIPELINE NMT</a:t>
             </a:r>
           </a:p>
           <a:p>
@@ -4813,7 +6472,7 @@
               </a:defRPr>
             </a:pPr>
             <a:r>
-              <a:t>Los 4 Modelos Comparados y sus Tokenizadores</a:t>
+              <a:t>El Embedding: Del Espacio Discreto al Continuo</a:t>
             </a:r>
           </a:p>
         </p:txBody>
@@ -4826,157 +6485,8 @@
         </p:nvSpPr>
         <p:spPr>
           <a:xfrm>
-            <a:off x="548640" y="1371600"/>
-            <a:ext cx="2560320" cy="4846320"/>
-          </a:xfrm>
-          <a:prstGeom prst="rect">
-            <a:avLst/>
-          </a:prstGeom>
-          <a:solidFill>
-            <a:srgbClr val="121626"/>
-          </a:solidFill>
-          <a:ln w="12700">
-            <a:solidFill>
-              <a:srgbClr val="8B5CF6"/>
-            </a:solidFill>
-          </a:ln>
-        </p:spPr>
-        <p:style>
-          <a:lnRef idx="1">
-            <a:schemeClr val="accent1"/>
-          </a:lnRef>
-          <a:fillRef idx="3">
-            <a:schemeClr val="accent1"/>
-          </a:fillRef>
-          <a:effectRef idx="2">
-            <a:schemeClr val="accent1"/>
-          </a:effectRef>
-          <a:fontRef idx="minor">
-            <a:schemeClr val="lt1"/>
-          </a:fontRef>
-        </p:style>
-        <p:txBody>
-          <a:bodyPr rtlCol="0" anchor="ctr"/>
-          <a:lstStyle/>
-          <a:p>
-            <a:pPr algn="ctr"/>
-          </a:p>
-        </p:txBody>
-      </p:sp>
-      <p:sp>
-        <p:nvSpPr>
-          <p:cNvPr id="7" name="TextBox 6"/>
-          <p:cNvSpPr txBox="1"/>
-          <p:nvPr/>
-        </p:nvSpPr>
-        <p:spPr>
-          <a:xfrm>
-            <a:off x="640080" y="1508760"/>
-            <a:ext cx="2377440" cy="4572000"/>
-          </a:xfrm>
-          <a:prstGeom prst="rect">
-            <a:avLst/>
-          </a:prstGeom>
-          <a:noFill/>
-        </p:spPr>
-        <p:txBody>
-          <a:bodyPr wrap="square">
-            <a:spAutoFit/>
-          </a:bodyPr>
-          <a:lstStyle/>
-          <a:p/>
-          <a:p>
-            <a:pPr algn="l">
-              <a:spcBef>
-                <a:spcPts val="0"/>
-              </a:spcBef>
-              <a:spcAft>
-                <a:spcPts val="800"/>
-              </a:spcAft>
-              <a:defRPr sz="1300" b="1" i="0">
-                <a:solidFill>
-                  <a:srgbClr val="8B5CF6"/>
-                </a:solidFill>
-                <a:latin typeface="Arial"/>
-              </a:defRPr>
-            </a:pPr>
-            <a:r>
-              <a:t>1. NLLB + LoRA</a:t>
-            </a:r>
-            <a:br/>
-            <a:r>
-              <a:t>Fine-Tuned</a:t>
-            </a:r>
-          </a:p>
-          <a:p>
-            <a:pPr algn="l">
-              <a:spcBef>
-                <a:spcPts val="0"/>
-              </a:spcBef>
-              <a:spcAft>
-                <a:spcPts val="600"/>
-              </a:spcAft>
-              <a:defRPr sz="1000" b="0" i="0">
-                <a:solidFill>
-                  <a:srgbClr val="FFFFFF"/>
-                </a:solidFill>
-                <a:latin typeface="Arial"/>
-              </a:defRPr>
-            </a:pPr>
-            <a:r>
-              <a:t>• Tokenizador: SentencePiece especializado.</a:t>
-            </a:r>
-          </a:p>
-          <a:p>
-            <a:pPr algn="l">
-              <a:spcBef>
-                <a:spcPts val="0"/>
-              </a:spcBef>
-              <a:spcAft>
-                <a:spcPts val="600"/>
-              </a:spcAft>
-              <a:defRPr sz="1000" b="0" i="0">
-                <a:solidFill>
-                  <a:srgbClr val="FFFFFF"/>
-                </a:solidFill>
-                <a:latin typeface="Arial"/>
-              </a:defRPr>
-            </a:pPr>
-            <a:r>
-              <a:t>• Vocabulario: 256,206 subpalabras nativas de 'ayr_Latn'.</a:t>
-            </a:r>
-          </a:p>
-          <a:p>
-            <a:pPr algn="l">
-              <a:spcBef>
-                <a:spcPts val="0"/>
-              </a:spcBef>
-              <a:spcAft>
-                <a:spcPts val="600"/>
-              </a:spcAft>
-              <a:defRPr sz="1000" b="0" i="0">
-                <a:solidFill>
-                  <a:srgbClr val="FFFFFF"/>
-                </a:solidFill>
-                <a:latin typeface="Arial"/>
-              </a:defRPr>
-            </a:pPr>
-            <a:r>
-              <a:t>• Efecto: Excelente salud. Aísla las raíces y los sufijos morfológicos completos respetando la gramática.</a:t>
-            </a:r>
-          </a:p>
-        </p:txBody>
-      </p:sp>
-      <p:sp>
-        <p:nvSpPr>
-          <p:cNvPr id="8" name="Rectangle 7"/>
-          <p:cNvSpPr/>
-          <p:nvPr/>
-        </p:nvSpPr>
-        <p:spPr>
-          <a:xfrm>
-            <a:off x="3337560" y="1371600"/>
-            <a:ext cx="2560320" cy="4846320"/>
+            <a:off x="548640" y="1188720"/>
+            <a:ext cx="5394960" cy="5212080"/>
           </a:xfrm>
           <a:prstGeom prst="rect">
             <a:avLst/>
@@ -5014,14 +6524,14 @@
       </p:sp>
       <p:sp>
         <p:nvSpPr>
-          <p:cNvPr id="9" name="TextBox 8"/>
+          <p:cNvPr id="7" name="TextBox 6"/>
           <p:cNvSpPr txBox="1"/>
           <p:nvPr/>
         </p:nvSpPr>
         <p:spPr>
           <a:xfrm>
-            <a:off x="3429000" y="1508760"/>
-            <a:ext cx="2377440" cy="4572000"/>
+            <a:off x="713232" y="1353312"/>
+            <a:ext cx="5065776" cy="4882896"/>
           </a:xfrm>
           <a:prstGeom prst="rect">
             <a:avLst/>
@@ -5042,7 +6552,26 @@
               <a:spcAft>
                 <a:spcPts val="800"/>
               </a:spcAft>
-              <a:defRPr sz="1300" b="1" i="0">
+              <a:defRPr sz="1400" b="1" i="0">
+                <a:solidFill>
+                  <a:srgbClr val="06B6D4"/>
+                </a:solidFill>
+                <a:latin typeface="Arial"/>
+              </a:defRPr>
+            </a:pPr>
+            <a:r>
+              <a:t>La Matriz de Embeddings</a:t>
+            </a:r>
+          </a:p>
+          <a:p>
+            <a:pPr algn="l">
+              <a:spcBef>
+                <a:spcPts val="0"/>
+              </a:spcBef>
+              <a:spcAft>
+                <a:spcPts val="600"/>
+              </a:spcAft>
+              <a:defRPr sz="1150" b="0" i="0">
                 <a:solidFill>
                   <a:srgbClr val="FFFFFF"/>
                 </a:solidFill>
@@ -5050,11 +6579,7 @@
               </a:defRPr>
             </a:pPr>
             <a:r>
-              <a:t>2. NLLB Base</a:t>
-            </a:r>
-            <a:br/>
-            <a:r>
-              <a:t>Original Meta</a:t>
+              <a:t>• Las redes neuronales no procesan enteros planos. La capa de Embedding traduce cada Token ID discreto a un vector numérico continuo y denso.</a:t>
             </a:r>
           </a:p>
           <a:p>
@@ -5065,7 +6590,7 @@
               <a:spcAft>
                 <a:spcPts val="600"/>
               </a:spcAft>
-              <a:defRPr sz="1000" b="0" i="0">
+              <a:defRPr sz="1150" b="0" i="0">
                 <a:solidFill>
                   <a:srgbClr val="FFFFFF"/>
                 </a:solidFill>
@@ -5073,7 +6598,7 @@
               </a:defRPr>
             </a:pPr>
             <a:r>
-              <a:t>• Tokenizador: SentencePiece.</a:t>
+              <a:t>• El modelo NLLB-200 utiliza una dimensión de representación interna ($d_{model} = 1024$).</a:t>
             </a:r>
           </a:p>
           <a:p>
@@ -5084,7 +6609,7 @@
               <a:spcAft>
                 <a:spcPts val="600"/>
               </a:spcAft>
-              <a:defRPr sz="1000" b="0" i="0">
+              <a:defRPr sz="1150" b="0" i="0">
                 <a:solidFill>
                   <a:srgbClr val="FFFFFF"/>
                 </a:solidFill>
@@ -5092,40 +6617,21 @@
               </a:defRPr>
             </a:pPr>
             <a:r>
-              <a:t>• Vocabulario: 256,206.</a:t>
-            </a:r>
-          </a:p>
-          <a:p>
-            <a:pPr algn="l">
-              <a:spcBef>
-                <a:spcPts val="0"/>
-              </a:spcBef>
-              <a:spcAft>
-                <a:spcPts val="600"/>
-              </a:spcAft>
-              <a:defRPr sz="1000" b="0" i="0">
-                <a:solidFill>
-                  <a:srgbClr val="FFFFFF"/>
-                </a:solidFill>
-                <a:latin typeface="Arial"/>
-              </a:defRPr>
-            </a:pPr>
-            <a:r>
-              <a:t>• Efecto: Mismo vocabulario estructural, pero carece de fine-tuning para mapear las relaciones morfológicas a nivel semántico.</a:t>
-            </a:r>
-          </a:p>
-        </p:txBody>
-      </p:sp>
-      <p:sp>
-        <p:nvSpPr>
-          <p:cNvPr id="10" name="Rectangle 9"/>
+              <a:t>• Cada token es representado por una fila en la matriz de pesos del embedding de tamaño ($V \times d_{model}$), donde $V = 256k$.</a:t>
+            </a:r>
+          </a:p>
+        </p:txBody>
+      </p:sp>
+      <p:sp>
+        <p:nvSpPr>
+          <p:cNvPr id="8" name="Rectangle 7"/>
           <p:cNvSpPr/>
           <p:nvPr/>
         </p:nvSpPr>
         <p:spPr>
           <a:xfrm>
-            <a:off x="6126480" y="1371600"/>
-            <a:ext cx="2560320" cy="4846320"/>
+            <a:off x="6428232" y="1188720"/>
+            <a:ext cx="5394960" cy="5212080"/>
           </a:xfrm>
           <a:prstGeom prst="rect">
             <a:avLst/>
@@ -5135,7 +6641,7 @@
           </a:solidFill>
           <a:ln w="12700">
             <a:solidFill>
-              <a:srgbClr val="F59E0B"/>
+              <a:srgbClr val="1E293B"/>
             </a:solidFill>
           </a:ln>
         </p:spPr>
@@ -5163,14 +6669,14 @@
       </p:sp>
       <p:sp>
         <p:nvSpPr>
-          <p:cNvPr id="11" name="TextBox 10"/>
+          <p:cNvPr id="9" name="TextBox 8"/>
           <p:cNvSpPr txBox="1"/>
           <p:nvPr/>
         </p:nvSpPr>
         <p:spPr>
           <a:xfrm>
-            <a:off x="6217920" y="1508760"/>
-            <a:ext cx="2377440" cy="4572000"/>
+            <a:off x="6592824" y="1353312"/>
+            <a:ext cx="5065776" cy="4882896"/>
           </a:xfrm>
           <a:prstGeom prst="rect">
             <a:avLst/>
@@ -5191,7 +6697,64 @@
               <a:spcAft>
                 <a:spcPts val="800"/>
               </a:spcAft>
-              <a:defRPr sz="1300" b="1" i="0">
+              <a:defRPr sz="1400" b="1" i="0">
+                <a:solidFill>
+                  <a:srgbClr val="8B5CF6"/>
+                </a:solidFill>
+                <a:latin typeface="Arial"/>
+              </a:defRPr>
+            </a:pPr>
+            <a:r>
+              <a:t>Adición de Información Posicional</a:t>
+            </a:r>
+          </a:p>
+          <a:p>
+            <a:pPr algn="l">
+              <a:spcBef>
+                <a:spcPts val="0"/>
+              </a:spcBef>
+              <a:spcAft>
+                <a:spcPts val="600"/>
+              </a:spcAft>
+              <a:defRPr sz="1150" b="0" i="0">
+                <a:solidFill>
+                  <a:srgbClr val="FFFFFF"/>
+                </a:solidFill>
+                <a:latin typeface="Arial"/>
+              </a:defRPr>
+            </a:pPr>
+            <a:r>
+              <a:t>• Dado que la arquitectura Transformer procesa todos los tokens en paralelo (sin recurrencia), carece de noción de orden secuencial.</a:t>
+            </a:r>
+          </a:p>
+          <a:p>
+            <a:pPr algn="l">
+              <a:spcBef>
+                <a:spcPts val="0"/>
+              </a:spcBef>
+              <a:spcAft>
+                <a:spcPts val="600"/>
+              </a:spcAft>
+              <a:defRPr sz="1150" b="0" i="0">
+                <a:solidFill>
+                  <a:srgbClr val="FFFFFF"/>
+                </a:solidFill>
+                <a:latin typeface="Arial"/>
+              </a:defRPr>
+            </a:pPr>
+            <a:r>
+              <a:t>• Para resolver esto, se suma al vector del embedding un vector posicional (Positional Encoding):</a:t>
+            </a:r>
+          </a:p>
+          <a:p>
+            <a:pPr algn="ctr">
+              <a:spcBef>
+                <a:spcPts val="0"/>
+              </a:spcBef>
+              <a:spcAft>
+                <a:spcPts val="1000"/>
+              </a:spcAft>
+              <a:defRPr sz="1100" b="1" i="0">
                 <a:solidFill>
                   <a:srgbClr val="F59E0B"/>
                 </a:solidFill>
@@ -5199,11 +6762,7 @@
               </a:defRPr>
             </a:pPr>
             <a:r>
-              <a:t>3. Llama-3-8B</a:t>
-            </a:r>
-            <a:br/>
-            <a:r>
-              <a:t>Meta LLM</a:t>
+              <a:t>Vector_Final = Embedding(ID) + Positional_Encoding</a:t>
             </a:r>
           </a:p>
           <a:p>
@@ -5214,7 +6773,7 @@
               <a:spcAft>
                 <a:spcPts val="600"/>
               </a:spcAft>
-              <a:defRPr sz="1000" b="0" i="0">
+              <a:defRPr sz="1150" b="0" i="0">
                 <a:solidFill>
                   <a:srgbClr val="FFFFFF"/>
                 </a:solidFill>
@@ -5222,194 +6781,7 @@
               </a:defRPr>
             </a:pPr>
             <a:r>
-              <a:t>• Tokenizador: Tiktoken BPE.</a:t>
-            </a:r>
-          </a:p>
-          <a:p>
-            <a:pPr algn="l">
-              <a:spcBef>
-                <a:spcPts val="0"/>
-              </a:spcBef>
-              <a:spcAft>
-                <a:spcPts val="600"/>
-              </a:spcAft>
-              <a:defRPr sz="1000" b="0" i="0">
-                <a:solidFill>
-                  <a:srgbClr val="FFFFFF"/>
-                </a:solidFill>
-                <a:latin typeface="Arial"/>
-              </a:defRPr>
-            </a:pPr>
-            <a:r>
-              <a:t>• Vocabulario: 128,256 general.</a:t>
-            </a:r>
-          </a:p>
-          <a:p>
-            <a:pPr algn="l">
-              <a:spcBef>
-                <a:spcPts val="0"/>
-              </a:spcBef>
-              <a:spcAft>
-                <a:spcPts val="600"/>
-              </a:spcAft>
-              <a:defRPr sz="1000" b="0" i="0">
-                <a:solidFill>
-                  <a:srgbClr val="FFFFFF"/>
-                </a:solidFill>
-                <a:latin typeface="Arial"/>
-              </a:defRPr>
-            </a:pPr>
-            <a:r>
-              <a:t>• Efecto: Colapso por sobrefragmentación. Al carecer de pre-entrenamiento en Aimara, corta palabras largas en minúsculos trozos sin sentido.</a:t>
-            </a:r>
-          </a:p>
-        </p:txBody>
-      </p:sp>
-      <p:sp>
-        <p:nvSpPr>
-          <p:cNvPr id="12" name="Rectangle 11"/>
-          <p:cNvSpPr/>
-          <p:nvPr/>
-        </p:nvSpPr>
-        <p:spPr>
-          <a:xfrm>
-            <a:off x="8915400" y="1371600"/>
-            <a:ext cx="2560320" cy="4846320"/>
-          </a:xfrm>
-          <a:prstGeom prst="rect">
-            <a:avLst/>
-          </a:prstGeom>
-          <a:solidFill>
-            <a:srgbClr val="121626"/>
-          </a:solidFill>
-          <a:ln w="12700">
-            <a:solidFill>
-              <a:srgbClr val="06B6D4"/>
-            </a:solidFill>
-          </a:ln>
-        </p:spPr>
-        <p:style>
-          <a:lnRef idx="1">
-            <a:schemeClr val="accent1"/>
-          </a:lnRef>
-          <a:fillRef idx="3">
-            <a:schemeClr val="accent1"/>
-          </a:fillRef>
-          <a:effectRef idx="2">
-            <a:schemeClr val="accent1"/>
-          </a:effectRef>
-          <a:fontRef idx="minor">
-            <a:schemeClr val="lt1"/>
-          </a:fontRef>
-        </p:style>
-        <p:txBody>
-          <a:bodyPr rtlCol="0" anchor="ctr"/>
-          <a:lstStyle/>
-          <a:p>
-            <a:pPr algn="ctr"/>
-          </a:p>
-        </p:txBody>
-      </p:sp>
-      <p:sp>
-        <p:nvSpPr>
-          <p:cNvPr id="13" name="TextBox 12"/>
-          <p:cNvSpPr txBox="1"/>
-          <p:nvPr/>
-        </p:nvSpPr>
-        <p:spPr>
-          <a:xfrm>
-            <a:off x="9006840" y="1508760"/>
-            <a:ext cx="2377440" cy="4572000"/>
-          </a:xfrm>
-          <a:prstGeom prst="rect">
-            <a:avLst/>
-          </a:prstGeom>
-          <a:noFill/>
-        </p:spPr>
-        <p:txBody>
-          <a:bodyPr wrap="square">
-            <a:spAutoFit/>
-          </a:bodyPr>
-          <a:lstStyle/>
-          <a:p/>
-          <a:p>
-            <a:pPr algn="l">
-              <a:spcBef>
-                <a:spcPts val="0"/>
-              </a:spcBef>
-              <a:spcAft>
-                <a:spcPts val="800"/>
-              </a:spcAft>
-              <a:defRPr sz="1300" b="1" i="0">
-                <a:solidFill>
-                  <a:srgbClr val="06B6D4"/>
-                </a:solidFill>
-                <a:latin typeface="Arial"/>
-              </a:defRPr>
-            </a:pPr>
-            <a:r>
-              <a:t>4. Gemma-2-9B</a:t>
-            </a:r>
-            <a:br/>
-            <a:r>
-              <a:t>Google LLM</a:t>
-            </a:r>
-          </a:p>
-          <a:p>
-            <a:pPr algn="l">
-              <a:spcBef>
-                <a:spcPts val="0"/>
-              </a:spcBef>
-              <a:spcAft>
-                <a:spcPts val="600"/>
-              </a:spcAft>
-              <a:defRPr sz="1000" b="0" i="0">
-                <a:solidFill>
-                  <a:srgbClr val="FFFFFF"/>
-                </a:solidFill>
-                <a:latin typeface="Arial"/>
-              </a:defRPr>
-            </a:pPr>
-            <a:r>
-              <a:t>• Tokenizador: SentencePiece masivo.</a:t>
-            </a:r>
-          </a:p>
-          <a:p>
-            <a:pPr algn="l">
-              <a:spcBef>
-                <a:spcPts val="0"/>
-              </a:spcBef>
-              <a:spcAft>
-                <a:spcPts val="600"/>
-              </a:spcAft>
-              <a:defRPr sz="1000" b="0" i="0">
-                <a:solidFill>
-                  <a:srgbClr val="FFFFFF"/>
-                </a:solidFill>
-                <a:latin typeface="Arial"/>
-              </a:defRPr>
-            </a:pPr>
-            <a:r>
-              <a:t>• Vocabulario: 256,000 multilingüe.</a:t>
-            </a:r>
-          </a:p>
-          <a:p>
-            <a:pPr algn="l">
-              <a:spcBef>
-                <a:spcPts val="0"/>
-              </a:spcBef>
-              <a:spcAft>
-                <a:spcPts val="600"/>
-              </a:spcAft>
-              <a:defRPr sz="1000" b="0" i="0">
-                <a:solidFill>
-                  <a:srgbClr val="FFFFFF"/>
-                </a:solidFill>
-                <a:latin typeface="Arial"/>
-              </a:defRPr>
-            </a:pPr>
-            <a:r>
-              <a:t>• Efecto: Moderado. Aunque gestiona mejor los espacios debido al algoritmo SP, fragmenta en exceso las flexiones aglutinantes por falta de corpus base.</a:t>
+              <a:t>• Esto inyecta la posición exacta de cada palabra dentro del espacio sintáctico, permitiendo capturar el orden lógico gramatical.</a:t>
             </a:r>
           </a:p>
         </p:txBody>
@@ -5564,7 +6936,7 @@
               </a:defRPr>
             </a:pPr>
             <a:r>
-              <a:t>5 / 9</a:t>
+              <a:t>5 / 13</a:t>
             </a:r>
           </a:p>
         </p:txBody>
@@ -5607,7 +6979,7 @@
               </a:defRPr>
             </a:pPr>
             <a:r>
-              <a:t>EVIDENCIA CUANTITATIVA DE TOKENIZACIÓN</a:t>
+              <a:t>FASE 4 DEL PIPELINE NMT</a:t>
             </a:r>
           </a:p>
           <a:p>
@@ -5618,7 +6990,7 @@
               <a:spcAft>
                 <a:spcPts val="800"/>
               </a:spcAft>
-              <a:defRPr sz="2300" b="1" i="0">
+              <a:defRPr sz="2400" b="1" i="0">
                 <a:solidFill>
                   <a:srgbClr val="FFFFFF"/>
                 </a:solidFill>
@@ -5626,45 +6998,166 @@
               </a:defRPr>
             </a:pPr>
             <a:r>
-              <a:t>Batalla de Fragmentación: Recuento de Tokens por Modelo</a:t>
-            </a:r>
-          </a:p>
-        </p:txBody>
-      </p:sp>
-      <p:pic>
-        <p:nvPicPr>
-          <p:cNvPr id="6" name="Picture 5" descr="image.png"/>
-          <p:cNvPicPr>
-            <a:picLocks noChangeAspect="1"/>
-          </p:cNvPicPr>
-          <p:nvPr/>
-        </p:nvPicPr>
-        <p:blipFill>
-          <a:blip r:embed="rId2"/>
-          <a:stretch>
-            <a:fillRect/>
-          </a:stretch>
-        </p:blipFill>
-        <p:spPr>
-          <a:xfrm>
-            <a:off x="548640" y="1188720"/>
-            <a:ext cx="6858000" cy="4114800"/>
-          </a:xfrm>
-          <a:prstGeom prst="rect">
-            <a:avLst/>
-          </a:prstGeom>
-        </p:spPr>
-      </p:pic>
-      <p:sp>
-        <p:nvSpPr>
-          <p:cNvPr id="7" name="Rectangle 6"/>
+              <a:t>Vectores de Palabras y Proximidad del Espacio Semántico</a:t>
+            </a:r>
+          </a:p>
+        </p:txBody>
+      </p:sp>
+      <p:sp>
+        <p:nvSpPr>
+          <p:cNvPr id="6" name="Rectangle 5"/>
           <p:cNvSpPr/>
           <p:nvPr/>
         </p:nvSpPr>
         <p:spPr>
           <a:xfrm>
-            <a:off x="7680960" y="1188720"/>
-            <a:ext cx="3931920" cy="4114800"/>
+            <a:off x="548640" y="1188720"/>
+            <a:ext cx="5394960" cy="5212080"/>
+          </a:xfrm>
+          <a:prstGeom prst="rect">
+            <a:avLst/>
+          </a:prstGeom>
+          <a:solidFill>
+            <a:srgbClr val="121626"/>
+          </a:solidFill>
+          <a:ln w="12700">
+            <a:solidFill>
+              <a:srgbClr val="06B6D4"/>
+            </a:solidFill>
+          </a:ln>
+        </p:spPr>
+        <p:style>
+          <a:lnRef idx="1">
+            <a:schemeClr val="accent1"/>
+          </a:lnRef>
+          <a:fillRef idx="3">
+            <a:schemeClr val="accent1"/>
+          </a:fillRef>
+          <a:effectRef idx="2">
+            <a:schemeClr val="accent1"/>
+          </a:effectRef>
+          <a:fontRef idx="minor">
+            <a:schemeClr val="lt1"/>
+          </a:fontRef>
+        </p:style>
+        <p:txBody>
+          <a:bodyPr rtlCol="0" anchor="ctr"/>
+          <a:lstStyle/>
+          <a:p>
+            <a:pPr algn="ctr"/>
+          </a:p>
+        </p:txBody>
+      </p:sp>
+      <p:sp>
+        <p:nvSpPr>
+          <p:cNvPr id="7" name="TextBox 6"/>
+          <p:cNvSpPr txBox="1"/>
+          <p:nvPr/>
+        </p:nvSpPr>
+        <p:spPr>
+          <a:xfrm>
+            <a:off x="713232" y="1353312"/>
+            <a:ext cx="5065776" cy="4882896"/>
+          </a:xfrm>
+          <a:prstGeom prst="rect">
+            <a:avLst/>
+          </a:prstGeom>
+          <a:noFill/>
+        </p:spPr>
+        <p:txBody>
+          <a:bodyPr wrap="square">
+            <a:spAutoFit/>
+          </a:bodyPr>
+          <a:lstStyle/>
+          <a:p/>
+          <a:p>
+            <a:pPr algn="l">
+              <a:spcBef>
+                <a:spcPts val="0"/>
+              </a:spcBef>
+              <a:spcAft>
+                <a:spcPts val="800"/>
+              </a:spcAft>
+              <a:defRPr sz="1500" b="1" i="0">
+                <a:solidFill>
+                  <a:srgbClr val="06B6D4"/>
+                </a:solidFill>
+                <a:latin typeface="Arial"/>
+              </a:defRPr>
+            </a:pPr>
+            <a:r>
+              <a:t>Geometría del Significado</a:t>
+            </a:r>
+          </a:p>
+          <a:p>
+            <a:pPr algn="l">
+              <a:spcBef>
+                <a:spcPts val="0"/>
+              </a:spcBef>
+              <a:spcAft>
+                <a:spcPts val="600"/>
+              </a:spcAft>
+              <a:defRPr sz="1150" b="0" i="0">
+                <a:solidFill>
+                  <a:srgbClr val="FFFFFF"/>
+                </a:solidFill>
+                <a:latin typeface="Arial"/>
+              </a:defRPr>
+            </a:pPr>
+            <a:r>
+              <a:t>• En el espacio continuo de 1024 dimensiones, los tokens con significados semánticos similares se agrupan geométricamente cerca unos de otros.</a:t>
+            </a:r>
+          </a:p>
+          <a:p>
+            <a:pPr algn="l">
+              <a:spcBef>
+                <a:spcPts val="0"/>
+              </a:spcBef>
+              <a:spcAft>
+                <a:spcPts val="600"/>
+              </a:spcAft>
+              <a:defRPr sz="1150" b="0" i="0">
+                <a:solidFill>
+                  <a:srgbClr val="FFFFFF"/>
+                </a:solidFill>
+                <a:latin typeface="Arial"/>
+              </a:defRPr>
+            </a:pPr>
+            <a:r>
+              <a:t>• Esto permite a la red comprender que 'kamisaraki' y 'hola' comparten la misma zona de representación, a pesar de pertenecer a lenguas distintas.</a:t>
+            </a:r>
+          </a:p>
+          <a:p>
+            <a:pPr algn="l">
+              <a:spcBef>
+                <a:spcPts val="0"/>
+              </a:spcBef>
+              <a:spcAft>
+                <a:spcPts val="600"/>
+              </a:spcAft>
+              <a:defRPr sz="1150" b="0" i="0">
+                <a:solidFill>
+                  <a:srgbClr val="FFFFFF"/>
+                </a:solidFill>
+                <a:latin typeface="Arial"/>
+              </a:defRPr>
+            </a:pPr>
+            <a:r>
+              <a:t>• Relaciones de Analogía: El espacio conserva simetrías lógicas, como capturar las declinaciones de género, persona y número.</a:t>
+            </a:r>
+          </a:p>
+        </p:txBody>
+      </p:sp>
+      <p:sp>
+        <p:nvSpPr>
+          <p:cNvPr id="8" name="Rectangle 7"/>
+          <p:cNvSpPr/>
+          <p:nvPr/>
+        </p:nvSpPr>
+        <p:spPr>
+          <a:xfrm>
+            <a:off x="6428232" y="1188720"/>
+            <a:ext cx="5394960" cy="5212080"/>
           </a:xfrm>
           <a:prstGeom prst="rect">
             <a:avLst/>
@@ -5702,14 +7195,14 @@
       </p:sp>
       <p:sp>
         <p:nvSpPr>
-          <p:cNvPr id="8" name="TextBox 7"/>
+          <p:cNvPr id="9" name="TextBox 8"/>
           <p:cNvSpPr txBox="1"/>
           <p:nvPr/>
         </p:nvSpPr>
         <p:spPr>
           <a:xfrm>
-            <a:off x="7863840" y="1371600"/>
-            <a:ext cx="3566160" cy="3749039"/>
+            <a:off x="6592824" y="1353312"/>
+            <a:ext cx="5065776" cy="4882896"/>
           </a:xfrm>
           <a:prstGeom prst="rect">
             <a:avLst/>
@@ -5730,7 +7223,7 @@
               <a:spcAft>
                 <a:spcPts val="800"/>
               </a:spcAft>
-              <a:defRPr sz="1400" b="1" i="0">
+              <a:defRPr sz="1500" b="1" i="0">
                 <a:solidFill>
                   <a:srgbClr val="8B5CF6"/>
                 </a:solidFill>
@@ -5738,7 +7231,7 @@
               </a:defRPr>
             </a:pPr>
             <a:r>
-              <a:t>Análisis de Fragmentación</a:t>
+              <a:t>Cálculo de Proximidad Coseno</a:t>
             </a:r>
           </a:p>
           <a:p>
@@ -5757,7 +7250,26 @@
               </a:defRPr>
             </a:pPr>
             <a:r>
-              <a:t>• NLLB-200 especializado logra tokenizar la palabra de 34 caracteres en solo 11 tokens morfológicos lógicos.</a:t>
+              <a:t>• Para medir qué tan parecidas son dos palabras matemáticamente, la red calcula el coseno del ángulo entre sus vectores (Cosine Similarity):</a:t>
+            </a:r>
+          </a:p>
+          <a:p>
+            <a:pPr algn="ctr">
+              <a:spcBef>
+                <a:spcPts val="0"/>
+              </a:spcBef>
+              <a:spcAft>
+                <a:spcPts val="800"/>
+              </a:spcAft>
+              <a:defRPr sz="1100" b="1" i="0">
+                <a:solidFill>
+                  <a:srgbClr val="F59E0B"/>
+                </a:solidFill>
+                <a:latin typeface="Arial"/>
+              </a:defRPr>
+            </a:pPr>
+            <a:r>
+              <a:t>Sim(A, B) = cos(θ) = (A · B) / (||A|| ||B||)</a:t>
             </a:r>
           </a:p>
           <a:p>
@@ -5776,7 +7288,7 @@
               </a:defRPr>
             </a:pPr>
             <a:r>
-              <a:t>• Llama-3-8B colapsa dividiendo la misma palabra en 17 micro-tokens incoherentes debido a la falta de cobertura en su vocabulario BPE.</a:t>
+              <a:t>• Si los vectores apuntan en la misma dirección (Sim ≈ 1.0), los términos son sinónimos u oraciones con traducción equivalente.</a:t>
             </a:r>
           </a:p>
           <a:p>
@@ -5795,45 +7307,7 @@
               </a:defRPr>
             </a:pPr>
             <a:r>
-              <a:t>• Gemma-2 logra un recuento bajo (9 tokens) cortando bloques ciegos de 4 caracteres, pero destruyendo la estructura de sufijos y raíces.</a:t>
-            </a:r>
-          </a:p>
-          <a:p>
-            <a:pPr algn="l">
-              <a:spcBef>
-                <a:spcPts val="0"/>
-              </a:spcBef>
-              <a:spcAft>
-                <a:spcPts val="400"/>
-              </a:spcAft>
-              <a:defRPr sz="700" b="0" i="0">
-                <a:solidFill>
-                  <a:srgbClr val="94A3B8"/>
-                </a:solidFill>
-                <a:latin typeface="Arial"/>
-              </a:defRPr>
-            </a:pPr>
-            <a:r>
-              <a:t>────────────────────────────────────────────────────────────────────</a:t>
-            </a:r>
-          </a:p>
-          <a:p>
-            <a:pPr algn="l">
-              <a:spcBef>
-                <a:spcPts val="0"/>
-              </a:spcBef>
-              <a:spcAft>
-                <a:spcPts val="600"/>
-              </a:spcAft>
-              <a:defRPr sz="1150" b="0" i="0">
-                <a:solidFill>
-                  <a:srgbClr val="FFFFFF"/>
-                </a:solidFill>
-                <a:latin typeface="Arial"/>
-              </a:defRPr>
-            </a:pPr>
-            <a:r>
-              <a:t>• Menor fragmentación a nivel morfológico reduce significativamente la entropía y optimiza el contexto del mecanismo de atención.</a:t>
+              <a:t>• Esto provee una representación matemática robusta y abstracta que unifica el Español y el Aimara.</a:t>
             </a:r>
           </a:p>
         </p:txBody>
@@ -5988,7 +7462,7 @@
               </a:defRPr>
             </a:pPr>
             <a:r>
-              <a:t>6 / 9</a:t>
+              <a:t>6 / 13</a:t>
             </a:r>
           </a:p>
         </p:txBody>
@@ -6031,7 +7505,7 @@
               </a:defRPr>
             </a:pPr>
             <a:r>
-              <a:t>EVIDENCIA CUANTITATIVA DE TOKENIZACIÓN</a:t>
+              <a:t>FASE 5 DEL PIPELINE NMT</a:t>
             </a:r>
           </a:p>
           <a:p>
@@ -6042,7 +7516,7 @@
               <a:spcAft>
                 <a:spcPts val="800"/>
               </a:spcAft>
-              <a:defRPr sz="2300" b="1" i="0">
+              <a:defRPr sz="2400" b="1" i="0">
                 <a:solidFill>
                   <a:srgbClr val="FFFFFF"/>
                 </a:solidFill>
@@ -6050,45 +7524,21 @@
               </a:defRPr>
             </a:pPr>
             <a:r>
-              <a:t>Coherencia de Slicing: Longitud Promedio de Tokens</a:t>
-            </a:r>
-          </a:p>
-        </p:txBody>
-      </p:sp>
-      <p:pic>
-        <p:nvPicPr>
-          <p:cNvPr id="6" name="Picture 5" descr="image.png"/>
-          <p:cNvPicPr>
-            <a:picLocks noChangeAspect="1"/>
-          </p:cNvPicPr>
-          <p:nvPr/>
-        </p:nvPicPr>
-        <p:blipFill>
-          <a:blip r:embed="rId2"/>
-          <a:stretch>
-            <a:fillRect/>
-          </a:stretch>
-        </p:blipFill>
-        <p:spPr>
-          <a:xfrm>
-            <a:off x="548640" y="1188720"/>
-            <a:ext cx="6858000" cy="4114800"/>
-          </a:xfrm>
-          <a:prstGeom prst="rect">
-            <a:avLst/>
-          </a:prstGeom>
-        </p:spPr>
-      </p:pic>
-      <p:sp>
-        <p:nvSpPr>
-          <p:cNvPr id="7" name="Rectangle 6"/>
+              <a:t>Arquitecturas para Machine Translation: Seq2Seq Transformers</a:t>
+            </a:r>
+          </a:p>
+        </p:txBody>
+      </p:sp>
+      <p:sp>
+        <p:nvSpPr>
+          <p:cNvPr id="6" name="Rectangle 5"/>
           <p:cNvSpPr/>
           <p:nvPr/>
         </p:nvSpPr>
         <p:spPr>
           <a:xfrm>
-            <a:off x="7680960" y="1188720"/>
-            <a:ext cx="3931920" cy="4114800"/>
+            <a:off x="548640" y="1188720"/>
+            <a:ext cx="5394960" cy="5212080"/>
           </a:xfrm>
           <a:prstGeom prst="rect">
             <a:avLst/>
@@ -6098,7 +7548,7 @@
           </a:solidFill>
           <a:ln w="12700">
             <a:solidFill>
-              <a:srgbClr val="06B6D4"/>
+              <a:srgbClr val="1E293B"/>
             </a:solidFill>
           </a:ln>
         </p:spPr>
@@ -6126,14 +7576,14 @@
       </p:sp>
       <p:sp>
         <p:nvSpPr>
-          <p:cNvPr id="8" name="TextBox 7"/>
+          <p:cNvPr id="7" name="TextBox 6"/>
           <p:cNvSpPr txBox="1"/>
           <p:nvPr/>
         </p:nvSpPr>
         <p:spPr>
           <a:xfrm>
-            <a:off x="7863840" y="1371600"/>
-            <a:ext cx="3566160" cy="3749039"/>
+            <a:off x="713232" y="1353312"/>
+            <a:ext cx="5065776" cy="4882896"/>
           </a:xfrm>
           <a:prstGeom prst="rect">
             <a:avLst/>
@@ -6162,7 +7612,7 @@
               </a:defRPr>
             </a:pPr>
             <a:r>
-              <a:t>Longitud y Coherencia Semántica</a:t>
+              <a:t>El Rol del Encoder (Español)</a:t>
             </a:r>
           </a:p>
           <a:p>
@@ -6181,7 +7631,7 @@
               </a:defRPr>
             </a:pPr>
             <a:r>
-              <a:t>• NLLB-200 mantiene un promedio de 3.1 caracteres por token, resguardando la integridad semántica de raíces y morfemas.</a:t>
+              <a:t>• El Encoder lee la secuencia de vectores del Español y computa capas de Multi-Head Self-Attention.</a:t>
             </a:r>
           </a:p>
           <a:p>
@@ -6200,7 +7650,7 @@
               </a:defRPr>
             </a:pPr>
             <a:r>
-              <a:t>• Llama-3 sufre una caída drástica a 2.0 caracteres por token, fragmentando a nivel de caracteres individuales sin semántica léxica.</a:t>
+              <a:t>• Esto permite relacionar cada palabra con todo su contexto circundante en la oración fuente (por ejemplo, entender si 'banco' refiere a una entidad financiera o un mueble para sentarse).</a:t>
             </a:r>
           </a:p>
           <a:p>
@@ -6219,26 +7669,95 @@
               </a:defRPr>
             </a:pPr>
             <a:r>
-              <a:t>• Gemma-2 promedia 3.8 caracteres por token debido a una estructura SP masiva que divide rígidamente bloques de longitud fija de 4 letras.</a:t>
-            </a:r>
-          </a:p>
-          <a:p>
-            <a:pPr algn="l">
-              <a:spcBef>
-                <a:spcPts val="0"/>
-              </a:spcBef>
-              <a:spcAft>
-                <a:spcPts val="400"/>
-              </a:spcAft>
-              <a:defRPr sz="700" b="0" i="0">
-                <a:solidFill>
-                  <a:srgbClr val="94A3B8"/>
-                </a:solidFill>
-                <a:latin typeface="Arial"/>
-              </a:defRPr>
-            </a:pPr>
-            <a:r>
-              <a:t>────────────────────────────────────────────────────────────────────</a:t>
+              <a:t>• Produce una representación de estados ocultos contextualizada para toda la frase de entrada.</a:t>
+            </a:r>
+          </a:p>
+        </p:txBody>
+      </p:sp>
+      <p:sp>
+        <p:nvSpPr>
+          <p:cNvPr id="8" name="Rectangle 7"/>
+          <p:cNvSpPr/>
+          <p:nvPr/>
+        </p:nvSpPr>
+        <p:spPr>
+          <a:xfrm>
+            <a:off x="6428232" y="1188720"/>
+            <a:ext cx="5394960" cy="5212080"/>
+          </a:xfrm>
+          <a:prstGeom prst="rect">
+            <a:avLst/>
+          </a:prstGeom>
+          <a:solidFill>
+            <a:srgbClr val="121626"/>
+          </a:solidFill>
+          <a:ln w="12700">
+            <a:solidFill>
+              <a:srgbClr val="1E293B"/>
+            </a:solidFill>
+          </a:ln>
+        </p:spPr>
+        <p:style>
+          <a:lnRef idx="1">
+            <a:schemeClr val="accent1"/>
+          </a:lnRef>
+          <a:fillRef idx="3">
+            <a:schemeClr val="accent1"/>
+          </a:fillRef>
+          <a:effectRef idx="2">
+            <a:schemeClr val="accent1"/>
+          </a:effectRef>
+          <a:fontRef idx="minor">
+            <a:schemeClr val="lt1"/>
+          </a:fontRef>
+        </p:style>
+        <p:txBody>
+          <a:bodyPr rtlCol="0" anchor="ctr"/>
+          <a:lstStyle/>
+          <a:p>
+            <a:pPr algn="ctr"/>
+          </a:p>
+        </p:txBody>
+      </p:sp>
+      <p:sp>
+        <p:nvSpPr>
+          <p:cNvPr id="9" name="TextBox 8"/>
+          <p:cNvSpPr txBox="1"/>
+          <p:nvPr/>
+        </p:nvSpPr>
+        <p:spPr>
+          <a:xfrm>
+            <a:off x="6592824" y="1353312"/>
+            <a:ext cx="5065776" cy="4882896"/>
+          </a:xfrm>
+          <a:prstGeom prst="rect">
+            <a:avLst/>
+          </a:prstGeom>
+          <a:noFill/>
+        </p:spPr>
+        <p:txBody>
+          <a:bodyPr wrap="square">
+            <a:spAutoFit/>
+          </a:bodyPr>
+          <a:lstStyle/>
+          <a:p/>
+          <a:p>
+            <a:pPr algn="l">
+              <a:spcBef>
+                <a:spcPts val="0"/>
+              </a:spcBef>
+              <a:spcAft>
+                <a:spcPts val="800"/>
+              </a:spcAft>
+              <a:defRPr sz="1400" b="1" i="0">
+                <a:solidFill>
+                  <a:srgbClr val="8B5CF6"/>
+                </a:solidFill>
+                <a:latin typeface="Arial"/>
+              </a:defRPr>
+            </a:pPr>
+            <a:r>
+              <a:t>El Decoder y la Atención Cruzada (Aimara)</a:t>
             </a:r>
           </a:p>
           <a:p>
@@ -6257,7 +7776,45 @@
               </a:defRPr>
             </a:pPr>
             <a:r>
-              <a:t>• Un largo de token balanceado que mapee con los límites morfológicos es la clave para la convergencia científica en lenguas polisintéticas.</a:t>
+              <a:t>• El Decoder genera los tokens en Aimara de forma autorregresiva (uno a uno de izquierda a derecha).</a:t>
+            </a:r>
+          </a:p>
+          <a:p>
+            <a:pPr algn="l">
+              <a:spcBef>
+                <a:spcPts val="0"/>
+              </a:spcBef>
+              <a:spcAft>
+                <a:spcPts val="600"/>
+              </a:spcAft>
+              <a:defRPr sz="1150" b="0" i="0">
+                <a:solidFill>
+                  <a:srgbClr val="FFFFFF"/>
+                </a:solidFill>
+                <a:latin typeface="Arial"/>
+              </a:defRPr>
+            </a:pPr>
+            <a:r>
+              <a:t>• Multi-Head Cross-Attention: En cada paso, el decoder asocia lo que está traduciendo con la representación contextual del encoder.</a:t>
+            </a:r>
+          </a:p>
+          <a:p>
+            <a:pPr algn="l">
+              <a:spcBef>
+                <a:spcPts val="0"/>
+              </a:spcBef>
+              <a:spcAft>
+                <a:spcPts val="600"/>
+              </a:spcAft>
+              <a:defRPr sz="1150" b="0" i="0">
+                <a:solidFill>
+                  <a:srgbClr val="FFFFFF"/>
+                </a:solidFill>
+                <a:latin typeface="Arial"/>
+              </a:defRPr>
+            </a:pPr>
+            <a:r>
+              <a:t>• Mecanismo de Proyección: La salida densa del decoder se proyecta a la dimensión del vocabulario ($256k$) aplicando softmax para elegir el Token ID de mayor probabilidad en Aimara.</a:t>
             </a:r>
           </a:p>
         </p:txBody>
@@ -6412,7 +7969,7 @@
               </a:defRPr>
             </a:pPr>
             <a:r>
-              <a:t>7 / 9</a:t>
+              <a:t>7 / 13</a:t>
             </a:r>
           </a:p>
         </p:txBody>
@@ -6455,7 +8012,7 @@
               </a:defRPr>
             </a:pPr>
             <a:r>
-              <a:t>DIDÁCTICA DE LA INTELIGENCIA ARTIFICIAL</a:t>
+              <a:t>MORFOLOGÍA DE LENGUAS ORIGINARIAS</a:t>
             </a:r>
           </a:p>
           <a:p>
@@ -6474,45 +8031,166 @@
               </a:defRPr>
             </a:pPr>
             <a:r>
-              <a:t>La Analogía Didáctica: Bloques LEGO y las Tijeras Inteligentes</a:t>
-            </a:r>
-          </a:p>
-        </p:txBody>
-      </p:sp>
-      <p:pic>
-        <p:nvPicPr>
-          <p:cNvPr id="6" name="Picture 5" descr="image.png"/>
-          <p:cNvPicPr>
-            <a:picLocks noChangeAspect="1"/>
-          </p:cNvPicPr>
-          <p:nvPr/>
-        </p:nvPicPr>
-        <p:blipFill>
-          <a:blip r:embed="rId2"/>
-          <a:stretch>
-            <a:fillRect/>
-          </a:stretch>
-        </p:blipFill>
-        <p:spPr>
-          <a:xfrm>
-            <a:off x="548640" y="1188720"/>
-            <a:ext cx="11064240" cy="3017520"/>
-          </a:xfrm>
-          <a:prstGeom prst="rect">
-            <a:avLst/>
-          </a:prstGeom>
-        </p:spPr>
-      </p:pic>
-      <p:sp>
-        <p:nvSpPr>
-          <p:cNvPr id="7" name="Rectangle 6"/>
+              <a:t>El Desafío Lingüístico: Morfología Aglutinante en Aimara</a:t>
+            </a:r>
+          </a:p>
+        </p:txBody>
+      </p:sp>
+      <p:sp>
+        <p:nvSpPr>
+          <p:cNvPr id="6" name="Rectangle 5"/>
           <p:cNvSpPr/>
           <p:nvPr/>
         </p:nvSpPr>
         <p:spPr>
           <a:xfrm>
-            <a:off x="548640" y="4389120"/>
-            <a:ext cx="11064240" cy="2011680"/>
+            <a:off x="548640" y="1188720"/>
+            <a:ext cx="5394960" cy="5212080"/>
+          </a:xfrm>
+          <a:prstGeom prst="rect">
+            <a:avLst/>
+          </a:prstGeom>
+          <a:solidFill>
+            <a:srgbClr val="121626"/>
+          </a:solidFill>
+          <a:ln w="12700">
+            <a:solidFill>
+              <a:srgbClr val="06B6D4"/>
+            </a:solidFill>
+          </a:ln>
+        </p:spPr>
+        <p:style>
+          <a:lnRef idx="1">
+            <a:schemeClr val="accent1"/>
+          </a:lnRef>
+          <a:fillRef idx="3">
+            <a:schemeClr val="accent1"/>
+          </a:fillRef>
+          <a:effectRef idx="2">
+            <a:schemeClr val="accent1"/>
+          </a:effectRef>
+          <a:fontRef idx="minor">
+            <a:schemeClr val="lt1"/>
+          </a:fontRef>
+        </p:style>
+        <p:txBody>
+          <a:bodyPr rtlCol="0" anchor="ctr"/>
+          <a:lstStyle/>
+          <a:p>
+            <a:pPr algn="ctr"/>
+          </a:p>
+        </p:txBody>
+      </p:sp>
+      <p:sp>
+        <p:nvSpPr>
+          <p:cNvPr id="7" name="TextBox 6"/>
+          <p:cNvSpPr txBox="1"/>
+          <p:nvPr/>
+        </p:nvSpPr>
+        <p:spPr>
+          <a:xfrm>
+            <a:off x="713232" y="1353312"/>
+            <a:ext cx="5065776" cy="4882896"/>
+          </a:xfrm>
+          <a:prstGeom prst="rect">
+            <a:avLst/>
+          </a:prstGeom>
+          <a:noFill/>
+        </p:spPr>
+        <p:txBody>
+          <a:bodyPr wrap="square">
+            <a:spAutoFit/>
+          </a:bodyPr>
+          <a:lstStyle/>
+          <a:p/>
+          <a:p>
+            <a:pPr algn="l">
+              <a:spcBef>
+                <a:spcPts val="0"/>
+              </a:spcBef>
+              <a:spcAft>
+                <a:spcPts val="800"/>
+              </a:spcAft>
+              <a:defRPr sz="1500" b="1" i="0">
+                <a:solidFill>
+                  <a:srgbClr val="06B6D4"/>
+                </a:solidFill>
+                <a:latin typeface="Arial"/>
+              </a:defRPr>
+            </a:pPr>
+            <a:r>
+              <a:t>Estructura Sintética Extrema</a:t>
+            </a:r>
+          </a:p>
+          <a:p>
+            <a:pPr algn="l">
+              <a:spcBef>
+                <a:spcPts val="0"/>
+              </a:spcBef>
+              <a:spcAft>
+                <a:spcPts val="600"/>
+              </a:spcAft>
+              <a:defRPr sz="1150" b="0" i="0">
+                <a:solidFill>
+                  <a:srgbClr val="FFFFFF"/>
+                </a:solidFill>
+                <a:latin typeface="Arial"/>
+              </a:defRPr>
+            </a:pPr>
+            <a:r>
+              <a:t>• A diferencia de las lenguas indoeuropeas (como el Español) donde las palabras se dividen limpiamente por espacios, el Aimara es una lengua polisintética y aglutinante.</a:t>
+            </a:r>
+          </a:p>
+          <a:p>
+            <a:pPr algn="l">
+              <a:spcBef>
+                <a:spcPts val="0"/>
+              </a:spcBef>
+              <a:spcAft>
+                <a:spcPts val="600"/>
+              </a:spcAft>
+              <a:defRPr sz="1150" b="0" i="0">
+                <a:solidFill>
+                  <a:srgbClr val="FFFFFF"/>
+                </a:solidFill>
+                <a:latin typeface="Arial"/>
+              </a:defRPr>
+            </a:pPr>
+            <a:r>
+              <a:t>• Las oraciones y conceptos sumamente complejos se construyen a partir de una raíz léxica a la cual se le añade en serie una cadena de múltiples morfemas (sufijos).</a:t>
+            </a:r>
+          </a:p>
+          <a:p>
+            <a:pPr algn="l">
+              <a:spcBef>
+                <a:spcPts val="0"/>
+              </a:spcBef>
+              <a:spcAft>
+                <a:spcPts val="600"/>
+              </a:spcAft>
+              <a:defRPr sz="1150" b="0" i="0">
+                <a:solidFill>
+                  <a:srgbClr val="FFFFFF"/>
+                </a:solidFill>
+                <a:latin typeface="Arial"/>
+              </a:defRPr>
+            </a:pPr>
+            <a:r>
+              <a:t>• Esto causa dispersión de vocabulario severa: una misma raíz nominal o verbal puede dar lugar a millones de formas flexivas únicas, haciendo inviable un vocabulario a nivel de palabra.</a:t>
+            </a:r>
+          </a:p>
+        </p:txBody>
+      </p:sp>
+      <p:sp>
+        <p:nvSpPr>
+          <p:cNvPr id="8" name="Rectangle 7"/>
+          <p:cNvSpPr/>
+          <p:nvPr/>
+        </p:nvSpPr>
+        <p:spPr>
+          <a:xfrm>
+            <a:off x="6428232" y="1188720"/>
+            <a:ext cx="5394960" cy="5212080"/>
           </a:xfrm>
           <a:prstGeom prst="rect">
             <a:avLst/>
@@ -6550,14 +8228,14 @@
       </p:sp>
       <p:sp>
         <p:nvSpPr>
-          <p:cNvPr id="8" name="TextBox 7"/>
+          <p:cNvPr id="9" name="TextBox 8"/>
           <p:cNvSpPr txBox="1"/>
           <p:nvPr/>
         </p:nvSpPr>
         <p:spPr>
           <a:xfrm>
-            <a:off x="731520" y="4480560"/>
-            <a:ext cx="10698480" cy="1828800"/>
+            <a:off x="6592824" y="1353312"/>
+            <a:ext cx="5065776" cy="4882896"/>
           </a:xfrm>
           <a:prstGeom prst="rect">
             <a:avLst/>
@@ -6578,15 +8256,15 @@
               <a:spcAft>
                 <a:spcPts val="800"/>
               </a:spcAft>
-              <a:defRPr sz="1400" b="1" i="0">
-                <a:solidFill>
-                  <a:srgbClr val="06B6D4"/>
-                </a:solidFill>
-                <a:latin typeface="Arial"/>
-              </a:defRPr>
-            </a:pPr>
-            <a:r>
-              <a:t>Explicación Didáctica para Ponencias Académicas</a:t>
+              <a:defRPr sz="1500" b="1" i="0">
+                <a:solidFill>
+                  <a:srgbClr val="8B5CF6"/>
+                </a:solidFill>
+                <a:latin typeface="Arial"/>
+              </a:defRPr>
+            </a:pPr>
+            <a:r>
+              <a:t>Análisis de Caso Insignia</a:t>
             </a:r>
           </a:p>
           <a:p>
@@ -6597,6 +8275,101 @@
               <a:spcAft>
                 <a:spcPts val="600"/>
               </a:spcAft>
+              <a:defRPr sz="1200" b="1" i="0">
+                <a:solidFill>
+                  <a:srgbClr val="FFFFFF"/>
+                </a:solidFill>
+                <a:latin typeface="Arial"/>
+              </a:defRPr>
+            </a:pPr>
+            <a:r>
+              <a:t>Palabra aglutinante extrema en Aimara:</a:t>
+            </a:r>
+          </a:p>
+          <a:p>
+            <a:pPr algn="ctr">
+              <a:spcBef>
+                <a:spcPts val="500"/>
+              </a:spcBef>
+              <a:spcAft>
+                <a:spcPts val="1000"/>
+              </a:spcAft>
+              <a:defRPr sz="1500" b="1" i="0">
+                <a:solidFill>
+                  <a:srgbClr val="F59E0B"/>
+                </a:solidFill>
+                <a:latin typeface="Arial"/>
+              </a:defRPr>
+            </a:pPr>
+            <a:r>
+              <a:t>aruskipapxañanakasakipunirakispawa</a:t>
+            </a:r>
+          </a:p>
+          <a:p>
+            <a:pPr algn="l">
+              <a:spcBef>
+                <a:spcPts val="0"/>
+              </a:spcBef>
+              <a:spcAft>
+                <a:spcPts val="600"/>
+              </a:spcAft>
+              <a:defRPr sz="1100" b="1" i="0">
+                <a:solidFill>
+                  <a:srgbClr val="94A3B8"/>
+                </a:solidFill>
+                <a:latin typeface="Arial"/>
+              </a:defRPr>
+            </a:pPr>
+            <a:r>
+              <a:t>Traducción humana exacta al Español:</a:t>
+            </a:r>
+          </a:p>
+          <a:p>
+            <a:pPr algn="ctr">
+              <a:spcBef>
+                <a:spcPts val="0"/>
+              </a:spcBef>
+              <a:spcAft>
+                <a:spcPts val="1500"/>
+              </a:spcAft>
+              <a:defRPr sz="1200" b="0" i="1">
+                <a:solidFill>
+                  <a:srgbClr val="FFFFFF"/>
+                </a:solidFill>
+                <a:latin typeface="Arial"/>
+              </a:defRPr>
+            </a:pPr>
+            <a:r>
+              <a:t>"Es una obligación mutua hablar entre nosotros de forma ineludible."</a:t>
+            </a:r>
+          </a:p>
+          <a:p>
+            <a:pPr algn="l">
+              <a:spcBef>
+                <a:spcPts val="0"/>
+              </a:spcBef>
+              <a:spcAft>
+                <a:spcPts val="400"/>
+              </a:spcAft>
+              <a:defRPr sz="700" b="0" i="0">
+                <a:solidFill>
+                  <a:srgbClr val="94A3B8"/>
+                </a:solidFill>
+                <a:latin typeface="Arial"/>
+              </a:defRPr>
+            </a:pPr>
+            <a:r>
+              <a:t>────────────────────────────────────────────────────────────────────</a:t>
+            </a:r>
+          </a:p>
+          <a:p>
+            <a:pPr algn="l">
+              <a:spcBef>
+                <a:spcPts val="0"/>
+              </a:spcBef>
+              <a:spcAft>
+                <a:spcPts val="600"/>
+              </a:spcAft>
               <a:defRPr sz="1150" b="0" i="0">
                 <a:solidFill>
                   <a:srgbClr val="FFFFFF"/>
@@ -6605,7 +8378,7 @@
               </a:defRPr>
             </a:pPr>
             <a:r>
-              <a:t>• El Aimara es como un juguete de bloques LEGO: las palabras largas se construyen encadenando pequeños bloquecitos (raíz + sufijos).</a:t>
+              <a:t>• Si alimentamos al Transformer con palabras enteras, el modelo sufrirá colapso por palabras fuera de vocabulario (OOV).</a:t>
             </a:r>
           </a:p>
           <a:p>
@@ -6624,26 +8397,7 @@
               </a:defRPr>
             </a:pPr>
             <a:r>
-              <a:t>• NLLB-200 es como usar 'tijeras inteligentes': Corta la palabra en las uniones de los bloques LEGO reales. Así, es sumamente fácil entender el significado de cada pieza y volver a unirlas de forma lógica.</a:t>
-            </a:r>
-          </a:p>
-          <a:p>
-            <a:pPr algn="l">
-              <a:spcBef>
-                <a:spcPts val="0"/>
-              </a:spcBef>
-              <a:spcAft>
-                <a:spcPts val="600"/>
-              </a:spcAft>
-              <a:defRPr sz="1150" b="0" i="0">
-                <a:solidFill>
-                  <a:srgbClr val="FFFFFF"/>
-                </a:solidFill>
-                <a:latin typeface="Arial"/>
-              </a:defRPr>
-            </a:pPr>
-            <a:r>
-              <a:t>• Llama-3-8B es como usar 'tijeras rotas': No conoce el idioma y corta los bloques LEGO a la mitad, dejándolos en diminutas astillas de dos letras que no significan nada, colapsando el cerebro del Transformer.</a:t>
+              <a:t>• Se requiere obligatoriamente segmentar a nivel de subpalabras (subwords) para que la red capture la raíz y los morfemas por separado.</a:t>
             </a:r>
           </a:p>
         </p:txBody>
@@ -6798,7 +8552,7 @@
               </a:defRPr>
             </a:pPr>
             <a:r>
-              <a:t>8 / 9</a:t>
+              <a:t>8 / 13</a:t>
             </a:r>
           </a:p>
         </p:txBody>
@@ -6841,7 +8595,7 @@
               </a:defRPr>
             </a:pPr>
             <a:r>
-              <a:t>MÉTRICAS CIENTÍFICAS</a:t>
+              <a:t>ARENA DE COMPARACIÓN DE IA</a:t>
             </a:r>
           </a:p>
           <a:p>
@@ -6860,7 +8614,7 @@
               </a:defRPr>
             </a:pPr>
             <a:r>
-              <a:t>El Tribunal Científico: BLEU vs ChrF++ en Lenguas Sintéticas</a:t>
+              <a:t>Los 4 Modelos Comparados y sus Tokenizadores</a:t>
             </a:r>
           </a:p>
         </p:txBody>
@@ -6873,8 +8627,153 @@
         </p:nvSpPr>
         <p:spPr>
           <a:xfrm>
-            <a:off x="548640" y="1188720"/>
-            <a:ext cx="5394960" cy="5212080"/>
+            <a:off x="548640" y="1371600"/>
+            <a:ext cx="2560320" cy="4846320"/>
+          </a:xfrm>
+          <a:prstGeom prst="rect">
+            <a:avLst/>
+          </a:prstGeom>
+          <a:solidFill>
+            <a:srgbClr val="121626"/>
+          </a:solidFill>
+          <a:ln w="12700">
+            <a:solidFill>
+              <a:srgbClr val="8B5CF6"/>
+            </a:solidFill>
+          </a:ln>
+        </p:spPr>
+        <p:style>
+          <a:lnRef idx="1">
+            <a:schemeClr val="accent1"/>
+          </a:lnRef>
+          <a:fillRef idx="3">
+            <a:schemeClr val="accent1"/>
+          </a:fillRef>
+          <a:effectRef idx="2">
+            <a:schemeClr val="accent1"/>
+          </a:effectRef>
+          <a:fontRef idx="minor">
+            <a:schemeClr val="lt1"/>
+          </a:fontRef>
+        </p:style>
+        <p:txBody>
+          <a:bodyPr rtlCol="0" anchor="ctr"/>
+          <a:lstStyle/>
+          <a:p>
+            <a:pPr algn="ctr"/>
+          </a:p>
+        </p:txBody>
+      </p:sp>
+      <p:sp>
+        <p:nvSpPr>
+          <p:cNvPr id="7" name="TextBox 6"/>
+          <p:cNvSpPr txBox="1"/>
+          <p:nvPr/>
+        </p:nvSpPr>
+        <p:spPr>
+          <a:xfrm>
+            <a:off x="640080" y="1508760"/>
+            <a:ext cx="2377440" cy="4572000"/>
+          </a:xfrm>
+          <a:prstGeom prst="rect">
+            <a:avLst/>
+          </a:prstGeom>
+          <a:noFill/>
+        </p:spPr>
+        <p:txBody>
+          <a:bodyPr wrap="square">
+            <a:spAutoFit/>
+          </a:bodyPr>
+          <a:lstStyle/>
+          <a:p/>
+          <a:p>
+            <a:pPr algn="l">
+              <a:spcBef>
+                <a:spcPts val="0"/>
+              </a:spcBef>
+              <a:spcAft>
+                <a:spcPts val="800"/>
+              </a:spcAft>
+              <a:defRPr sz="1300" b="1" i="0">
+                <a:solidFill>
+                  <a:srgbClr val="8B5CF6"/>
+                </a:solidFill>
+                <a:latin typeface="Arial"/>
+              </a:defRPr>
+            </a:pPr>
+            <a:r>
+              <a:t>1. NLLB + LoRA\nFine-Tuned</a:t>
+            </a:r>
+          </a:p>
+          <a:p>
+            <a:pPr algn="l">
+              <a:spcBef>
+                <a:spcPts val="0"/>
+              </a:spcBef>
+              <a:spcAft>
+                <a:spcPts val="600"/>
+              </a:spcAft>
+              <a:defRPr sz="1000" b="0" i="0">
+                <a:solidFill>
+                  <a:srgbClr val="FFFFFF"/>
+                </a:solidFill>
+                <a:latin typeface="Arial"/>
+              </a:defRPr>
+            </a:pPr>
+            <a:r>
+              <a:t>• Tokenizador: SentencePiece especializado.</a:t>
+            </a:r>
+          </a:p>
+          <a:p>
+            <a:pPr algn="l">
+              <a:spcBef>
+                <a:spcPts val="0"/>
+              </a:spcBef>
+              <a:spcAft>
+                <a:spcPts val="600"/>
+              </a:spcAft>
+              <a:defRPr sz="1000" b="0" i="0">
+                <a:solidFill>
+                  <a:srgbClr val="FFFFFF"/>
+                </a:solidFill>
+                <a:latin typeface="Arial"/>
+              </a:defRPr>
+            </a:pPr>
+            <a:r>
+              <a:t>• Vocabulario: 256,206 subpalabras nativas de 'ayr_Latn'.</a:t>
+            </a:r>
+          </a:p>
+          <a:p>
+            <a:pPr algn="l">
+              <a:spcBef>
+                <a:spcPts val="0"/>
+              </a:spcBef>
+              <a:spcAft>
+                <a:spcPts val="600"/>
+              </a:spcAft>
+              <a:defRPr sz="1000" b="0" i="0">
+                <a:solidFill>
+                  <a:srgbClr val="FFFFFF"/>
+                </a:solidFill>
+                <a:latin typeface="Arial"/>
+              </a:defRPr>
+            </a:pPr>
+            <a:r>
+              <a:t>• Efecto: Excelente salud. Aísla las raíces y los sufijos morfológicos completos respetando la gramática.</a:t>
+            </a:r>
+          </a:p>
+        </p:txBody>
+      </p:sp>
+      <p:sp>
+        <p:nvSpPr>
+          <p:cNvPr id="8" name="Rectangle 7"/>
+          <p:cNvSpPr/>
+          <p:nvPr/>
+        </p:nvSpPr>
+        <p:spPr>
+          <a:xfrm>
+            <a:off x="3337560" y="1371600"/>
+            <a:ext cx="2560320" cy="4846320"/>
           </a:xfrm>
           <a:prstGeom prst="rect">
             <a:avLst/>
@@ -6912,14 +8811,14 @@
       </p:sp>
       <p:sp>
         <p:nvSpPr>
-          <p:cNvPr id="7" name="TextBox 6"/>
+          <p:cNvPr id="9" name="TextBox 8"/>
           <p:cNvSpPr txBox="1"/>
           <p:nvPr/>
         </p:nvSpPr>
         <p:spPr>
           <a:xfrm>
-            <a:off x="713232" y="1353312"/>
-            <a:ext cx="5065776" cy="4882896"/>
+            <a:off x="3429000" y="1508760"/>
+            <a:ext cx="2377440" cy="4572000"/>
           </a:xfrm>
           <a:prstGeom prst="rect">
             <a:avLst/>
@@ -6940,15 +8839,15 @@
               <a:spcAft>
                 <a:spcPts val="800"/>
               </a:spcAft>
-              <a:defRPr sz="1400" b="1" i="0">
-                <a:solidFill>
-                  <a:srgbClr val="F59E0B"/>
-                </a:solidFill>
-                <a:latin typeface="Arial"/>
-              </a:defRPr>
-            </a:pPr>
-            <a:r>
-              <a:t>El Problema de BLEU (Palabra Completa)</a:t>
+              <a:defRPr sz="1300" b="1" i="0">
+                <a:solidFill>
+                  <a:srgbClr val="FFFFFF"/>
+                </a:solidFill>
+                <a:latin typeface="Arial"/>
+              </a:defRPr>
+            </a:pPr>
+            <a:r>
+              <a:t>2. NLLB Base\nOriginal Meta</a:t>
             </a:r>
           </a:p>
           <a:p>
@@ -6959,7 +8858,7 @@
               <a:spcAft>
                 <a:spcPts val="600"/>
               </a:spcAft>
-              <a:defRPr sz="1150" b="0" i="0">
+              <a:defRPr sz="1000" b="0" i="0">
                 <a:solidFill>
                   <a:srgbClr val="FFFFFF"/>
                 </a:solidFill>
@@ -6967,7 +8866,7 @@
               </a:defRPr>
             </a:pPr>
             <a:r>
-              <a:t>• BLEU (Bilingual Evaluation Understudy) evalúa precisión exacta a nivel de palabra completa.</a:t>
+              <a:t>• Tokenizador: SentencePiece.</a:t>
             </a:r>
           </a:p>
           <a:p>
@@ -6978,7 +8877,7 @@
               <a:spcAft>
                 <a:spcPts val="600"/>
               </a:spcAft>
-              <a:defRPr sz="1150" b="0" i="0">
+              <a:defRPr sz="1000" b="0" i="0">
                 <a:solidFill>
                   <a:srgbClr val="FFFFFF"/>
                 </a:solidFill>
@@ -6986,7 +8885,7 @@
               </a:defRPr>
             </a:pPr>
             <a:r>
-              <a:t>• En idiomas aglutinantes, omitir o errar un solo sufijo al final de una palabra larga (por ejemplo, el sufijo enfático '-wa') provoca que BLEU clasifique la palabra completa como 100% incorrecta.</a:t>
+              <a:t>• Vocabulario: 256,206.</a:t>
             </a:r>
           </a:p>
           <a:p>
@@ -6997,7 +8896,7 @@
               <a:spcAft>
                 <a:spcPts val="600"/>
               </a:spcAft>
-              <a:defRPr sz="1150" b="0" i="0">
+              <a:defRPr sz="1000" b="0" i="0">
                 <a:solidFill>
                   <a:srgbClr val="FFFFFF"/>
                 </a:solidFill>
@@ -7005,21 +8904,21 @@
               </a:defRPr>
             </a:pPr>
             <a:r>
-              <a:t>• Esto causa una subestimación crítica de la calidad real de los traductores automáticos neuronales.</a:t>
-            </a:r>
-          </a:p>
-        </p:txBody>
-      </p:sp>
-      <p:sp>
-        <p:nvSpPr>
-          <p:cNvPr id="8" name="Rectangle 7"/>
+              <a:t>• Efecto: Mismo vocabulario estructural, pero carece de fine-tuning para mapear las relaciones morfológicas a nivel semántico.</a:t>
+            </a:r>
+          </a:p>
+        </p:txBody>
+      </p:sp>
+      <p:sp>
+        <p:nvSpPr>
+          <p:cNvPr id="10" name="Rectangle 9"/>
           <p:cNvSpPr/>
           <p:nvPr/>
         </p:nvSpPr>
         <p:spPr>
           <a:xfrm>
-            <a:off x="6428232" y="1188720"/>
-            <a:ext cx="5394960" cy="5212080"/>
+            <a:off x="6126480" y="1371600"/>
+            <a:ext cx="2560320" cy="4846320"/>
           </a:xfrm>
           <a:prstGeom prst="rect">
             <a:avLst/>
@@ -7029,7 +8928,7 @@
           </a:solidFill>
           <a:ln w="12700">
             <a:solidFill>
-              <a:srgbClr val="1E293B"/>
+              <a:srgbClr val="F59E0B"/>
             </a:solidFill>
           </a:ln>
         </p:spPr>
@@ -7057,14 +8956,14 @@
       </p:sp>
       <p:sp>
         <p:nvSpPr>
-          <p:cNvPr id="9" name="TextBox 8"/>
+          <p:cNvPr id="11" name="TextBox 10"/>
           <p:cNvSpPr txBox="1"/>
           <p:nvPr/>
         </p:nvSpPr>
         <p:spPr>
           <a:xfrm>
-            <a:off x="6592824" y="1353312"/>
-            <a:ext cx="5065776" cy="4882896"/>
+            <a:off x="6217920" y="1508760"/>
+            <a:ext cx="2377440" cy="4572000"/>
           </a:xfrm>
           <a:prstGeom prst="rect">
             <a:avLst/>
@@ -7085,15 +8984,15 @@
               <a:spcAft>
                 <a:spcPts val="800"/>
               </a:spcAft>
-              <a:defRPr sz="1400" b="1" i="0">
-                <a:solidFill>
-                  <a:srgbClr val="10B981"/>
-                </a:solidFill>
-                <a:latin typeface="Arial"/>
-              </a:defRPr>
-            </a:pPr>
-            <a:r>
-              <a:t>La Solución Científica: ChrF++</a:t>
+              <a:defRPr sz="1300" b="1" i="0">
+                <a:solidFill>
+                  <a:srgbClr val="F59E0B"/>
+                </a:solidFill>
+                <a:latin typeface="Arial"/>
+              </a:defRPr>
+            </a:pPr>
+            <a:r>
+              <a:t>3. Llama-3-8B\nMeta LLM</a:t>
             </a:r>
           </a:p>
           <a:p>
@@ -7104,7 +9003,7 @@
               <a:spcAft>
                 <a:spcPts val="600"/>
               </a:spcAft>
-              <a:defRPr sz="1150" b="0" i="0">
+              <a:defRPr sz="1000" b="0" i="0">
                 <a:solidFill>
                   <a:srgbClr val="FFFFFF"/>
                 </a:solidFill>
@@ -7112,7 +9011,7 @@
               </a:defRPr>
             </a:pPr>
             <a:r>
-              <a:t>• ChrF++ extrae y compara n-gramas de caracteres además de palabras completas.</a:t>
+              <a:t>• Tokenizador: Tiktoken BPE.</a:t>
             </a:r>
           </a:p>
           <a:p>
@@ -7123,7 +9022,7 @@
               <a:spcAft>
                 <a:spcPts val="600"/>
               </a:spcAft>
-              <a:defRPr sz="1150" b="0" i="0">
+              <a:defRPr sz="1000" b="0" i="0">
                 <a:solidFill>
                   <a:srgbClr val="FFFFFF"/>
                 </a:solidFill>
@@ -7131,7 +9030,7 @@
               </a:defRPr>
             </a:pPr>
             <a:r>
-              <a:t>• Si el modelo traduce de manera morfológicamente coherente la raíz del verbo pero falla levemente en el sufijo, ChrF++ premia la coincidencia morfológica parcial.</a:t>
+              <a:t>• Vocabulario: 128,256 general.</a:t>
             </a:r>
           </a:p>
           <a:p>
@@ -7142,7 +9041,7 @@
               <a:spcAft>
                 <a:spcPts val="600"/>
               </a:spcAft>
-              <a:defRPr sz="1150" b="0" i="0">
+              <a:defRPr sz="1000" b="0" i="0">
                 <a:solidFill>
                   <a:srgbClr val="FFFFFF"/>
                 </a:solidFill>
@@ -7150,7 +9049,152 @@
               </a:defRPr>
             </a:pPr>
             <a:r>
-              <a:t>• Es la métrica recomendada por la comunidad científica (WMT, AmericasNLP) para evaluar con rigurosidad y justicia las lenguas originarias de las Américas.</a:t>
+              <a:t>• Efecto: Colapso por sobrefragmentación. Al carecer de pre-entrenamiento en Aimara, corta palabras largas en minúsculos trozos sin sentido.</a:t>
+            </a:r>
+          </a:p>
+        </p:txBody>
+      </p:sp>
+      <p:sp>
+        <p:nvSpPr>
+          <p:cNvPr id="12" name="Rectangle 11"/>
+          <p:cNvSpPr/>
+          <p:nvPr/>
+        </p:nvSpPr>
+        <p:spPr>
+          <a:xfrm>
+            <a:off x="8915400" y="1371600"/>
+            <a:ext cx="2560320" cy="4846320"/>
+          </a:xfrm>
+          <a:prstGeom prst="rect">
+            <a:avLst/>
+          </a:prstGeom>
+          <a:solidFill>
+            <a:srgbClr val="121626"/>
+          </a:solidFill>
+          <a:ln w="12700">
+            <a:solidFill>
+              <a:srgbClr val="06B6D4"/>
+            </a:solidFill>
+          </a:ln>
+        </p:spPr>
+        <p:style>
+          <a:lnRef idx="1">
+            <a:schemeClr val="accent1"/>
+          </a:lnRef>
+          <a:fillRef idx="3">
+            <a:schemeClr val="accent1"/>
+          </a:fillRef>
+          <a:effectRef idx="2">
+            <a:schemeClr val="accent1"/>
+          </a:effectRef>
+          <a:fontRef idx="minor">
+            <a:schemeClr val="lt1"/>
+          </a:fontRef>
+        </p:style>
+        <p:txBody>
+          <a:bodyPr rtlCol="0" anchor="ctr"/>
+          <a:lstStyle/>
+          <a:p>
+            <a:pPr algn="ctr"/>
+          </a:p>
+        </p:txBody>
+      </p:sp>
+      <p:sp>
+        <p:nvSpPr>
+          <p:cNvPr id="13" name="TextBox 12"/>
+          <p:cNvSpPr txBox="1"/>
+          <p:nvPr/>
+        </p:nvSpPr>
+        <p:spPr>
+          <a:xfrm>
+            <a:off x="9006840" y="1508760"/>
+            <a:ext cx="2377440" cy="4572000"/>
+          </a:xfrm>
+          <a:prstGeom prst="rect">
+            <a:avLst/>
+          </a:prstGeom>
+          <a:noFill/>
+        </p:spPr>
+        <p:txBody>
+          <a:bodyPr wrap="square">
+            <a:spAutoFit/>
+          </a:bodyPr>
+          <a:lstStyle/>
+          <a:p/>
+          <a:p>
+            <a:pPr algn="l">
+              <a:spcBef>
+                <a:spcPts val="0"/>
+              </a:spcBef>
+              <a:spcAft>
+                <a:spcPts val="800"/>
+              </a:spcAft>
+              <a:defRPr sz="1300" b="1" i="0">
+                <a:solidFill>
+                  <a:srgbClr val="06B6D4"/>
+                </a:solidFill>
+                <a:latin typeface="Arial"/>
+              </a:defRPr>
+            </a:pPr>
+            <a:r>
+              <a:t>4. Gemma-2-9B\nGoogle LLM</a:t>
+            </a:r>
+          </a:p>
+          <a:p>
+            <a:pPr algn="l">
+              <a:spcBef>
+                <a:spcPts val="0"/>
+              </a:spcBef>
+              <a:spcAft>
+                <a:spcPts val="600"/>
+              </a:spcAft>
+              <a:defRPr sz="1000" b="0" i="0">
+                <a:solidFill>
+                  <a:srgbClr val="FFFFFF"/>
+                </a:solidFill>
+                <a:latin typeface="Arial"/>
+              </a:defRPr>
+            </a:pPr>
+            <a:r>
+              <a:t>• Tokenizador: SentencePiece masivo.</a:t>
+            </a:r>
+          </a:p>
+          <a:p>
+            <a:pPr algn="l">
+              <a:spcBef>
+                <a:spcPts val="0"/>
+              </a:spcBef>
+              <a:spcAft>
+                <a:spcPts val="600"/>
+              </a:spcAft>
+              <a:defRPr sz="1000" b="0" i="0">
+                <a:solidFill>
+                  <a:srgbClr val="FFFFFF"/>
+                </a:solidFill>
+                <a:latin typeface="Arial"/>
+              </a:defRPr>
+            </a:pPr>
+            <a:r>
+              <a:t>• Vocabulario: 256,000 multilingüe.</a:t>
+            </a:r>
+          </a:p>
+          <a:p>
+            <a:pPr algn="l">
+              <a:spcBef>
+                <a:spcPts val="0"/>
+              </a:spcBef>
+              <a:spcAft>
+                <a:spcPts val="600"/>
+              </a:spcAft>
+              <a:defRPr sz="1000" b="0" i="0">
+                <a:solidFill>
+                  <a:srgbClr val="FFFFFF"/>
+                </a:solidFill>
+                <a:latin typeface="Arial"/>
+              </a:defRPr>
+            </a:pPr>
+            <a:r>
+              <a:t>• Efecto: Moderado. Aunque gestiona mejor los espacios debido al algoritmo SP, fragmenta en exceso las flexiones aglutinantes por falta de corpus base.</a:t>
             </a:r>
           </a:p>
         </p:txBody>
@@ -7196,7 +9240,7 @@
             <a:avLst/>
           </a:prstGeom>
           <a:solidFill>
-            <a:srgbClr val="10B981"/>
+            <a:srgbClr val="8B5CF6"/>
           </a:solidFill>
           <a:ln>
             <a:noFill/>
@@ -7305,21 +9349,107 @@
               </a:defRPr>
             </a:pPr>
             <a:r>
-              <a:t>9 / 9</a:t>
-            </a:r>
-          </a:p>
-        </p:txBody>
-      </p:sp>
-      <p:sp>
-        <p:nvSpPr>
-          <p:cNvPr id="5" name="Rectangle 4"/>
+              <a:t>9 / 13</a:t>
+            </a:r>
+          </a:p>
+        </p:txBody>
+      </p:sp>
+      <p:sp>
+        <p:nvSpPr>
+          <p:cNvPr id="5" name="TextBox 4"/>
+          <p:cNvSpPr txBox="1"/>
+          <p:nvPr/>
+        </p:nvSpPr>
+        <p:spPr>
+          <a:xfrm>
+            <a:off x="548640" y="182880"/>
+            <a:ext cx="11064240" cy="731520"/>
+          </a:xfrm>
+          <a:prstGeom prst="rect">
+            <a:avLst/>
+          </a:prstGeom>
+          <a:noFill/>
+        </p:spPr>
+        <p:txBody>
+          <a:bodyPr wrap="none">
+            <a:spAutoFit/>
+          </a:bodyPr>
+          <a:lstStyle/>
+          <a:p/>
+          <a:p>
+            <a:pPr algn="l">
+              <a:spcBef>
+                <a:spcPts val="0"/>
+              </a:spcBef>
+              <a:spcAft>
+                <a:spcPts val="400"/>
+              </a:spcAft>
+              <a:defRPr sz="850" b="1" i="0">
+                <a:solidFill>
+                  <a:srgbClr val="06B6D4"/>
+                </a:solidFill>
+                <a:latin typeface="Arial"/>
+              </a:defRPr>
+            </a:pPr>
+            <a:r>
+              <a:t>EVIDENCIA CUANTITATIVA DE TOKENIZACIÓN</a:t>
+            </a:r>
+          </a:p>
+          <a:p>
+            <a:pPr algn="l">
+              <a:spcBef>
+                <a:spcPts val="0"/>
+              </a:spcBef>
+              <a:spcAft>
+                <a:spcPts val="800"/>
+              </a:spcAft>
+              <a:defRPr sz="2300" b="1" i="0">
+                <a:solidFill>
+                  <a:srgbClr val="FFFFFF"/>
+                </a:solidFill>
+                <a:latin typeface="Arial"/>
+              </a:defRPr>
+            </a:pPr>
+            <a:r>
+              <a:t>Batalla de Fragmentación: Recuento de Tokens por Modelo</a:t>
+            </a:r>
+          </a:p>
+        </p:txBody>
+      </p:sp>
+      <p:pic>
+        <p:nvPicPr>
+          <p:cNvPr id="6" name="Picture 5" descr="image.png"/>
+          <p:cNvPicPr>
+            <a:picLocks noChangeAspect="1"/>
+          </p:cNvPicPr>
+          <p:nvPr/>
+        </p:nvPicPr>
+        <p:blipFill>
+          <a:blip r:embed="rId2"/>
+          <a:stretch>
+            <a:fillRect/>
+          </a:stretch>
+        </p:blipFill>
+        <p:spPr>
+          <a:xfrm>
+            <a:off x="548640" y="1188720"/>
+            <a:ext cx="6858000" cy="4114800"/>
+          </a:xfrm>
+          <a:prstGeom prst="rect">
+            <a:avLst/>
+          </a:prstGeom>
+        </p:spPr>
+      </p:pic>
+      <p:sp>
+        <p:nvSpPr>
+          <p:cNvPr id="7" name="Rectangle 6"/>
           <p:cNvSpPr/>
           <p:nvPr/>
         </p:nvSpPr>
         <p:spPr>
           <a:xfrm>
-            <a:off x="685800" y="731520"/>
-            <a:ext cx="10817352" cy="5303520"/>
+            <a:off x="7680960" y="1188720"/>
+            <a:ext cx="3931920" cy="4114800"/>
           </a:xfrm>
           <a:prstGeom prst="rect">
             <a:avLst/>
@@ -7329,7 +9459,7 @@
           </a:solidFill>
           <a:ln w="12700">
             <a:solidFill>
-              <a:srgbClr val="10B981"/>
+              <a:srgbClr val="8B5CF6"/>
             </a:solidFill>
           </a:ln>
         </p:spPr>
@@ -7357,14 +9487,14 @@
       </p:sp>
       <p:sp>
         <p:nvSpPr>
-          <p:cNvPr id="6" name="TextBox 5"/>
+          <p:cNvPr id="8" name="TextBox 7"/>
           <p:cNvSpPr txBox="1"/>
           <p:nvPr/>
         </p:nvSpPr>
         <p:spPr>
           <a:xfrm>
-            <a:off x="1005840" y="1005840"/>
-            <a:ext cx="10149840" cy="4937760"/>
+            <a:off x="7863840" y="1371600"/>
+            <a:ext cx="3566160" cy="3749039"/>
           </a:xfrm>
           <a:prstGeom prst="rect">
             <a:avLst/>
@@ -7383,28 +9513,104 @@
                 <a:spcPts val="0"/>
               </a:spcBef>
               <a:spcAft>
+                <a:spcPts val="800"/>
+              </a:spcAft>
+              <a:defRPr sz="1400" b="1" i="0">
+                <a:solidFill>
+                  <a:srgbClr val="8B5CF6"/>
+                </a:solidFill>
+                <a:latin typeface="Arial"/>
+              </a:defRPr>
+            </a:pPr>
+            <a:r>
+              <a:t>Análisis de Fragmentación</a:t>
+            </a:r>
+          </a:p>
+          <a:p>
+            <a:pPr algn="l">
+              <a:spcBef>
+                <a:spcPts val="0"/>
+              </a:spcBef>
+              <a:spcAft>
+                <a:spcPts val="600"/>
+              </a:spcAft>
+              <a:defRPr sz="1150" b="0" i="0">
+                <a:solidFill>
+                  <a:srgbClr val="FFFFFF"/>
+                </a:solidFill>
+                <a:latin typeface="Arial"/>
+              </a:defRPr>
+            </a:pPr>
+            <a:r>
+              <a:t>• NLLB-200 especializado logra tokenizar la palabra de 34 caracteres en solo 11 tokens morfológicos lógicos.</a:t>
+            </a:r>
+          </a:p>
+          <a:p>
+            <a:pPr algn="l">
+              <a:spcBef>
+                <a:spcPts val="0"/>
+              </a:spcBef>
+              <a:spcAft>
+                <a:spcPts val="600"/>
+              </a:spcAft>
+              <a:defRPr sz="1150" b="0" i="0">
+                <a:solidFill>
+                  <a:srgbClr val="FFFFFF"/>
+                </a:solidFill>
+                <a:latin typeface="Arial"/>
+              </a:defRPr>
+            </a:pPr>
+            <a:r>
+              <a:t>• Llama-3-8B colapsa dividiendo la misma palabra en 17 micro-tokens incoherentes debido a la falta de cobertura en su vocabulario BPE.</a:t>
+            </a:r>
+          </a:p>
+          <a:p>
+            <a:pPr algn="l">
+              <a:spcBef>
+                <a:spcPts val="0"/>
+              </a:spcBef>
+              <a:spcAft>
+                <a:spcPts val="600"/>
+              </a:spcAft>
+              <a:defRPr sz="1150" b="0" i="0">
+                <a:solidFill>
+                  <a:srgbClr val="FFFFFF"/>
+                </a:solidFill>
+                <a:latin typeface="Arial"/>
+              </a:defRPr>
+            </a:pPr>
+            <a:r>
+              <a:t>• Gemma-2 logra un recuento bajo (9 tokens) cortando bloques ciegos de 4 caracteres, pero destruyendo la estructura de sufijos y raíces.</a:t>
+            </a:r>
+          </a:p>
+          <a:p>
+            <a:pPr algn="l">
+              <a:spcBef>
+                <a:spcPts val="0"/>
+              </a:spcBef>
+              <a:spcAft>
                 <a:spcPts val="400"/>
               </a:spcAft>
-              <a:defRPr sz="850" b="1" i="0">
-                <a:solidFill>
-                  <a:srgbClr val="10B981"/>
-                </a:solidFill>
-                <a:latin typeface="Arial"/>
-              </a:defRPr>
-            </a:pPr>
-            <a:r>
-              <a:t>CONCLUSIONES ACADÉMICAS</a:t>
-            </a:r>
-          </a:p>
-          <a:p>
-            <a:pPr algn="l">
-              <a:spcBef>
-                <a:spcPts val="0"/>
-              </a:spcBef>
-              <a:spcAft>
-                <a:spcPts val="800"/>
-              </a:spcAft>
-              <a:defRPr sz="2400" b="1" i="0">
+              <a:defRPr sz="700" b="0" i="0">
+                <a:solidFill>
+                  <a:srgbClr val="94A3B8"/>
+                </a:solidFill>
+                <a:latin typeface="Arial"/>
+              </a:defRPr>
+            </a:pPr>
+            <a:r>
+              <a:t>────────────────────────────────────────────────────────────────────</a:t>
+            </a:r>
+          </a:p>
+          <a:p>
+            <a:pPr algn="l">
+              <a:spcBef>
+                <a:spcPts val="0"/>
+              </a:spcBef>
+              <a:spcAft>
+                <a:spcPts val="600"/>
+              </a:spcAft>
+              <a:defRPr sz="1150" b="0" i="0">
                 <a:solidFill>
                   <a:srgbClr val="FFFFFF"/>
                 </a:solidFill>
@@ -7412,159 +9618,7 @@
               </a:defRPr>
             </a:pPr>
             <a:r>
-              <a:t>Conclusiones y Líneas de Investigación Futura</a:t>
-            </a:r>
-          </a:p>
-          <a:p>
-            <a:pPr algn="l">
-              <a:spcBef>
-                <a:spcPts val="0"/>
-              </a:spcBef>
-              <a:spcAft>
-                <a:spcPts val="400"/>
-              </a:spcAft>
-              <a:defRPr sz="700" b="0" i="0">
-                <a:solidFill>
-                  <a:srgbClr val="94A3B8"/>
-                </a:solidFill>
-                <a:latin typeface="Arial"/>
-              </a:defRPr>
-            </a:pPr>
-            <a:r>
-              <a:t>────────────────────────────────────────────────────────────────────</a:t>
-            </a:r>
-          </a:p>
-          <a:p>
-            <a:pPr algn="l">
-              <a:spcBef>
-                <a:spcPts val="0"/>
-              </a:spcBef>
-              <a:spcAft>
-                <a:spcPts val="600"/>
-              </a:spcAft>
-              <a:defRPr sz="1150" b="0" i="0">
-                <a:solidFill>
-                  <a:srgbClr val="FFFFFF"/>
-                </a:solidFill>
-                <a:latin typeface="Arial"/>
-              </a:defRPr>
-            </a:pPr>
-            <a:r>
-              <a:t>• ✓ Superioridad de SentencePiece: El pre-entrenamiento de SentencePiece especializado en NLLB-200 supera drásticamente a los tokenizadores BPE generales de LLMs masivos en lenguas aglutinantes.</a:t>
-            </a:r>
-          </a:p>
-          <a:p>
-            <a:pPr algn="l">
-              <a:spcBef>
-                <a:spcPts val="0"/>
-              </a:spcBef>
-              <a:spcAft>
-                <a:spcPts val="600"/>
-              </a:spcAft>
-              <a:defRPr sz="1150" b="0" i="0">
-                <a:solidFill>
-                  <a:srgbClr val="FFFFFF"/>
-                </a:solidFill>
-                <a:latin typeface="Arial"/>
-              </a:defRPr>
-            </a:pPr>
-            <a:r>
-              <a:t>• ✓ Preservación Morfológica: Minimizar la fragmentación a nivel de raíz y sufijo es indispensable para optimizar la ventana de atención y acelerar la convergencia semántica en la GPU local.</a:t>
-            </a:r>
-          </a:p>
-          <a:p>
-            <a:pPr algn="l">
-              <a:spcBef>
-                <a:spcPts val="0"/>
-              </a:spcBef>
-              <a:spcAft>
-                <a:spcPts val="600"/>
-              </a:spcAft>
-              <a:defRPr sz="1150" b="0" i="0">
-                <a:solidFill>
-                  <a:srgbClr val="FFFFFF"/>
-                </a:solidFill>
-                <a:latin typeface="Arial"/>
-              </a:defRPr>
-            </a:pPr>
-            <a:r>
-              <a:t>• ✓ Viabilidad Local en RTX 5060: El fine-tuning eficiente mediante adaptadores de bajo rango (LoRA) permite una flexibilidad SOTA con solo ~18 MB de adaptadores independientes del modelo base.</a:t>
-            </a:r>
-          </a:p>
-          <a:p>
-            <a:pPr algn="l">
-              <a:spcBef>
-                <a:spcPts val="0"/>
-              </a:spcBef>
-              <a:spcAft>
-                <a:spcPts val="400"/>
-              </a:spcAft>
-              <a:defRPr sz="700" b="0" i="0">
-                <a:solidFill>
-                  <a:srgbClr val="94A3B8"/>
-                </a:solidFill>
-                <a:latin typeface="Arial"/>
-              </a:defRPr>
-            </a:pPr>
-            <a:r>
-              <a:t>────────────────────────────────────────────────────────────────────</a:t>
-            </a:r>
-          </a:p>
-          <a:p>
-            <a:pPr algn="l">
-              <a:spcBef>
-                <a:spcPts val="0"/>
-              </a:spcBef>
-              <a:spcAft>
-                <a:spcPts val="800"/>
-              </a:spcAft>
-              <a:defRPr sz="1500" b="1" i="0">
-                <a:solidFill>
-                  <a:srgbClr val="8B5CF6"/>
-                </a:solidFill>
-                <a:latin typeface="Arial"/>
-              </a:defRPr>
-            </a:pPr>
-            <a:r>
-              <a:t>Trabajo Futuro</a:t>
-            </a:r>
-          </a:p>
-          <a:p>
-            <a:pPr algn="l">
-              <a:spcBef>
-                <a:spcPts val="0"/>
-              </a:spcBef>
-              <a:spcAft>
-                <a:spcPts val="600"/>
-              </a:spcAft>
-              <a:defRPr sz="1150" b="0" i="0">
-                <a:solidFill>
-                  <a:srgbClr val="FFFFFF"/>
-                </a:solidFill>
-                <a:latin typeface="Arial"/>
-              </a:defRPr>
-            </a:pPr>
-            <a:r>
-              <a:t>• • Desarrollar un tokenizador SentencePiece híbrido morfológico supervisado por lingüistas aimaras.</a:t>
-            </a:r>
-          </a:p>
-          <a:p>
-            <a:pPr algn="l">
-              <a:spcBef>
-                <a:spcPts val="0"/>
-              </a:spcBef>
-              <a:spcAft>
-                <a:spcPts val="600"/>
-              </a:spcAft>
-              <a:defRPr sz="1150" b="0" i="0">
-                <a:solidFill>
-                  <a:srgbClr val="FFFFFF"/>
-                </a:solidFill>
-                <a:latin typeface="Arial"/>
-              </a:defRPr>
-            </a:pPr>
-            <a:r>
-              <a:t>• • Implementar pipelines Speech-to-Speech offline mediante cuantización Q4_K_M ejecutables en dispositivos periféricos y móviles.</a:t>
+              <a:t>• Menor fragmentación a nivel morfológico reduce significativamente la entropía y optimiza el contexto del mecanismo de atención.</a:t>
             </a:r>
           </a:p>
         </p:txBody>

</xml_diff>